<commit_message>
fix(youtube): remove photos from LinkedIn carousel covers
</commit_message>
<xml_diff>
--- a/youtube_assets/02_tool_call_parser/linkedin/carousel-tool-calls-linkedin-v2.pptx
+++ b/youtube_assets/02_tool_call_parser/linkedin/carousel-tool-calls-linkedin-v2.pptx
@@ -2,21 +2,21 @@
 <file path=ppt/presentation.xml><?xml version="1.0" encoding="utf-8"?>
 <p:presentation xmlns:p="http://schemas.openxmlformats.org/presentationml/2006/main">
   <p:sldMasterIdLst>
-    <p:sldMasterId xmlns:r="http://schemas.openxmlformats.org/officeDocument/2006/relationships" id="2147483648" r:id="Red71076665b5415b"/>
+    <p:sldMasterId xmlns:r="http://schemas.openxmlformats.org/officeDocument/2006/relationships" id="2147483648" r:id="Rfbb8035b05664543"/>
   </p:sldMasterIdLst>
   <p:notesMasterIdLst>
-    <p:notesMasterId xmlns:r="http://schemas.openxmlformats.org/officeDocument/2006/relationships" r:id="Rc0dee47c05554e2a"/>
+    <p:notesMasterId xmlns:r="http://schemas.openxmlformats.org/officeDocument/2006/relationships" r:id="R3e9859c1cbbd4392"/>
   </p:notesMasterIdLst>
   <p:sldIdLst>
-    <p:sldId xmlns:r="http://schemas.openxmlformats.org/officeDocument/2006/relationships" id="256" r:id="R75b3721c5c50472f"/>
-    <p:sldId xmlns:r="http://schemas.openxmlformats.org/officeDocument/2006/relationships" id="257" r:id="Re10175671d4f44b6"/>
-    <p:sldId xmlns:r="http://schemas.openxmlformats.org/officeDocument/2006/relationships" id="258" r:id="R302a9f883ff742e1"/>
-    <p:sldId xmlns:r="http://schemas.openxmlformats.org/officeDocument/2006/relationships" id="259" r:id="Rccb7f847e5ff4458"/>
-    <p:sldId xmlns:r="http://schemas.openxmlformats.org/officeDocument/2006/relationships" id="260" r:id="R31cc2a2dcd294f97"/>
-    <p:sldId xmlns:r="http://schemas.openxmlformats.org/officeDocument/2006/relationships" id="261" r:id="Reb9253ab79394316"/>
-    <p:sldId xmlns:r="http://schemas.openxmlformats.org/officeDocument/2006/relationships" id="262" r:id="R56a12bad094e4886"/>
-    <p:sldId xmlns:r="http://schemas.openxmlformats.org/officeDocument/2006/relationships" id="263" r:id="R7d5b0dd84b41425f"/>
-    <p:sldId xmlns:r="http://schemas.openxmlformats.org/officeDocument/2006/relationships" id="264" r:id="R7a7932172aaf4ea5"/>
+    <p:sldId xmlns:r="http://schemas.openxmlformats.org/officeDocument/2006/relationships" id="256" r:id="R3d961203576545b3"/>
+    <p:sldId xmlns:r="http://schemas.openxmlformats.org/officeDocument/2006/relationships" id="257" r:id="R18946ea3eef6487a"/>
+    <p:sldId xmlns:r="http://schemas.openxmlformats.org/officeDocument/2006/relationships" id="258" r:id="Re8a904cf28234ec6"/>
+    <p:sldId xmlns:r="http://schemas.openxmlformats.org/officeDocument/2006/relationships" id="259" r:id="Racd4a58b1f9740a8"/>
+    <p:sldId xmlns:r="http://schemas.openxmlformats.org/officeDocument/2006/relationships" id="260" r:id="Rf5b883bb442c4289"/>
+    <p:sldId xmlns:r="http://schemas.openxmlformats.org/officeDocument/2006/relationships" id="261" r:id="R967b330c3974481b"/>
+    <p:sldId xmlns:r="http://schemas.openxmlformats.org/officeDocument/2006/relationships" id="262" r:id="R543a2e9fe4654773"/>
+    <p:sldId xmlns:r="http://schemas.openxmlformats.org/officeDocument/2006/relationships" id="263" r:id="R1694866165e84240"/>
+    <p:sldId xmlns:r="http://schemas.openxmlformats.org/officeDocument/2006/relationships" id="264" r:id="R3de8de7f1f7f4184"/>
   </p:sldIdLst>
   <p:sldSz cx="10287000" cy="12858750"/>
   <p:notesSz cx="6858000" cy="9144000"/>
@@ -1078,7 +1078,7 @@
   </p:cSld>
   <p:clrMap bg1="lt1" tx1="dk1" bg2="lt2" tx2="dk2" accent1="accent1" accent2="accent2" accent3="accent3" accent4="accent4" accent5="accent5" accent6="accent6" hlink="hlink" folHlink="folHlink"/>
   <p:sldLayoutIdLst>
-    <p:sldLayoutId xmlns:r="http://schemas.openxmlformats.org/officeDocument/2006/relationships" id="2147483649" r:id="R9a69950a86404b5a"/>
+    <p:sldLayoutId xmlns:r="http://schemas.openxmlformats.org/officeDocument/2006/relationships" id="2147483649" r:id="Rbf063ef5c5794cf9"/>
   </p:sldLayoutIdLst>
   <p:txStyles>
     <p:titleStyle>
@@ -1624,119 +1624,85 @@
       <p:grpSpPr>
         <a:xfrm xmlns:a="http://schemas.openxmlformats.org/drawingml/2006/main"/>
       </p:grpSpPr>
-      <p:pic>
-        <p:nvPicPr>
-          <p:cNvPr id="11" name=""/>
-          <p:cNvPicPr>
-            <a:picLocks xmlns:a="http://schemas.openxmlformats.org/drawingml/2006/main" noChangeAspect="1"/>
-          </p:cNvPicPr>
-          <p:nvPr/>
-        </p:nvPicPr>
-        <p:blipFill>
-          <a:blip xmlns:r="http://schemas.openxmlformats.org/officeDocument/2006/relationships" xmlns:a="http://schemas.openxmlformats.org/drawingml/2006/main" r:embed="Rb377d7d80b9b4859"/>
-          <a:srcRect xmlns:a="http://schemas.openxmlformats.org/drawingml/2006/main" l="0" t="0" r="0" b="0"/>
-          <a:stretch xmlns:a="http://schemas.openxmlformats.org/drawingml/2006/main">
-            <a:fillRect l="0" t="0" r="0" b="0"/>
-          </a:stretch>
-        </p:blipFill>
-        <p:spPr>
-          <a:xfrm xmlns:a="http://schemas.openxmlformats.org/drawingml/2006/main">
-            <a:off x="0" y="0"/>
-            <a:ext cx="10287000" cy="12858750"/>
-          </a:xfrm>
-          <a:prstGeom xmlns:a="http://schemas.openxmlformats.org/drawingml/2006/main" prst="rect">
-            <a:avLst/>
-          </a:prstGeom>
-        </p:spPr>
-      </p:pic>
+      <p:sp>
+        <p:nvSpPr>
+          <p:cNvPr id="7" name="">
+            <a:extLst xmlns:a="http://schemas.openxmlformats.org/drawingml/2006/main">
+              <a:ext uri="{FF2B5EF4-FFF2-40B4-BE49-F238E27FC236}">
+                <a16:creationId xmlns:a16="http://schemas.microsoft.com/office/drawing/2014/main" id="{09D83FBB-E7A0-4606-9251-D0C9562D3720}"/>
+              </a:ext>
+            </a:extLst>
+          </p:cNvPr>
+          <p:cNvSpPr>
+            <a:spLocks xmlns:a="http://schemas.openxmlformats.org/drawingml/2006/main" noGrp="1"/>
+          </p:cNvSpPr>
+          <p:nvPr/>
+        </p:nvSpPr>
+        <p:spPr>
+          <a:xfrm xmlns:a="http://schemas.openxmlformats.org/drawingml/2006/main">
+            <a:off x="762000" y="1095375"/>
+            <a:ext cx="8763000" cy="457200"/>
+          </a:xfrm>
+          <a:prstGeom xmlns:a="http://schemas.openxmlformats.org/drawingml/2006/main" prst="rect">
+            <a:avLst/>
+          </a:prstGeom>
+          <a:noFill xmlns:a="http://schemas.openxmlformats.org/drawingml/2006/main"/>
+          <a:ln xmlns:a="http://schemas.openxmlformats.org/drawingml/2006/main" w="0">
+            <a:noFill/>
+          </a:ln>
+        </p:spPr>
+        <p:txBody>
+          <a:bodyPr xmlns:a="http://schemas.openxmlformats.org/drawingml/2006/main" lIns="0" tIns="0" rIns="0" bIns="0" anchor="t">
+            <a:noAutofit/>
+          </a:bodyPr>
+          <a:lstStyle xmlns:a="http://schemas.openxmlformats.org/drawingml/2006/main"/>
+          <a:p xmlns:a="http://schemas.openxmlformats.org/drawingml/2006/main">
+            <a:pPr algn="l">
+              <a:lnSpc>
+                <a:spcPct val="100000"/>
+              </a:lnSpc>
+              <a:buNone/>
+              <a:defRPr sz="1950" b="1">
+                <a:solidFill>
+                  <a:srgbClr val="C8FF00"/>
+                </a:solidFill>
+                <a:latin typeface="Menlo"/>
+                <a:ea typeface="Menlo"/>
+                <a:cs typeface="Menlo"/>
+              </a:defRPr>
+            </a:pPr>
+            <a:r>
+              <a:rPr sz="1950" b="1">
+                <a:solidFill>
+                  <a:srgbClr val="C8FF00"/>
+                </a:solidFill>
+                <a:latin typeface="Menlo"/>
+                <a:ea typeface="Menlo"/>
+                <a:cs typeface="Menlo"/>
+              </a:rPr>
+              <a:t>TOOL CALLING</a:t>
+            </a:r>
+          </a:p>
+        </p:txBody>
+      </p:sp>
       <p:sp>
         <p:nvSpPr>
           <p:cNvPr id="2" name="">
             <a:extLst xmlns:a="http://schemas.openxmlformats.org/drawingml/2006/main">
               <a:ext uri="{FF2B5EF4-FFF2-40B4-BE49-F238E27FC236}">
-                <a16:creationId xmlns:a16="http://schemas.microsoft.com/office/drawing/2014/main" id="{DB294041-8D01-4320-BBC3-5E7EFB53E492}"/>
-              </a:ext>
-            </a:extLst>
-          </p:cNvPr>
-          <p:cNvSpPr>
-            <a:spLocks xmlns:a="http://schemas.openxmlformats.org/drawingml/2006/main" noGrp="1"/>
-          </p:cNvSpPr>
-          <p:nvPr/>
-        </p:nvSpPr>
-        <p:spPr>
-          <a:xfrm xmlns:a="http://schemas.openxmlformats.org/drawingml/2006/main">
-            <a:off x="0" y="0"/>
-            <a:ext cx="5572125" cy="12858750"/>
-          </a:xfrm>
-          <a:prstGeom xmlns:a="http://schemas.openxmlformats.org/drawingml/2006/main" prst="rect">
-            <a:avLst/>
-          </a:prstGeom>
-          <a:solidFill xmlns:a="http://schemas.openxmlformats.org/drawingml/2006/main">
-            <a:srgbClr val="080808"/>
-          </a:solidFill>
-          <a:ln xmlns:a="http://schemas.openxmlformats.org/drawingml/2006/main" w="0">
-            <a:noFill/>
-          </a:ln>
-        </p:spPr>
-      </p:sp>
-      <p:sp>
-        <p:nvSpPr>
-          <p:cNvPr id="3" name="">
-            <a:extLst xmlns:a="http://schemas.openxmlformats.org/drawingml/2006/main">
-              <a:ext uri="{FF2B5EF4-FFF2-40B4-BE49-F238E27FC236}">
-                <a16:creationId xmlns:a16="http://schemas.microsoft.com/office/drawing/2014/main" id="{4D145C6F-CAD0-409A-9888-C3AE275E2576}"/>
-              </a:ext>
-            </a:extLst>
-          </p:cNvPr>
-          <p:cNvSpPr>
-            <a:spLocks xmlns:a="http://schemas.openxmlformats.org/drawingml/2006/main" noGrp="1"/>
-          </p:cNvSpPr>
-          <p:nvPr/>
-        </p:nvSpPr>
-        <p:spPr>
-          <a:xfrm xmlns:a="http://schemas.openxmlformats.org/drawingml/2006/main">
-            <a:off x="5572125" y="0"/>
-            <a:ext cx="1619250" cy="12858750"/>
-          </a:xfrm>
-          <a:prstGeom xmlns:a="http://schemas.openxmlformats.org/drawingml/2006/main" prst="rect">
-            <a:avLst/>
-          </a:prstGeom>
-          <a:gradFill xmlns:a="http://schemas.openxmlformats.org/drawingml/2006/main">
-            <a:gsLst>
-              <a:gs pos="0">
-                <a:srgbClr val="080808"/>
-              </a:gs>
-              <a:gs pos="100000">
-                <a:srgbClr val="080808">
-                  <a:alpha val="0"/>
-                </a:srgbClr>
-              </a:gs>
-            </a:gsLst>
-            <a:lin ang="0"/>
-          </a:gradFill>
-          <a:ln xmlns:a="http://schemas.openxmlformats.org/drawingml/2006/main" w="0">
-            <a:noFill/>
-          </a:ln>
-        </p:spPr>
-      </p:sp>
-      <p:sp>
-        <p:nvSpPr>
-          <p:cNvPr id="4" name="">
-            <a:extLst xmlns:a="http://schemas.openxmlformats.org/drawingml/2006/main">
-              <a:ext uri="{FF2B5EF4-FFF2-40B4-BE49-F238E27FC236}">
-                <a16:creationId xmlns:a16="http://schemas.microsoft.com/office/drawing/2014/main" id="{659AE951-CE46-46EA-9622-3156D6AB98A3}"/>
-              </a:ext>
-            </a:extLst>
-          </p:cNvPr>
-          <p:cNvSpPr>
-            <a:spLocks xmlns:a="http://schemas.openxmlformats.org/drawingml/2006/main" noGrp="1"/>
-          </p:cNvSpPr>
-          <p:nvPr/>
-        </p:nvSpPr>
-        <p:spPr>
-          <a:xfrm xmlns:a="http://schemas.openxmlformats.org/drawingml/2006/main">
-            <a:off x="762000" y="1047750"/>
-            <a:ext cx="4095750" cy="457200"/>
+                <a16:creationId xmlns:a16="http://schemas.microsoft.com/office/drawing/2014/main" id="{36CBC5AB-A2AB-4380-858C-7E0BF4ED6659}"/>
+              </a:ext>
+            </a:extLst>
+          </p:cNvPr>
+          <p:cNvSpPr>
+            <a:spLocks xmlns:a="http://schemas.openxmlformats.org/drawingml/2006/main" noGrp="1"/>
+          </p:cNvSpPr>
+          <p:nvPr/>
+        </p:nvSpPr>
+        <p:spPr>
+          <a:xfrm xmlns:a="http://schemas.openxmlformats.org/drawingml/2006/main">
+            <a:off x="762000" y="2238375"/>
+            <a:ext cx="8763000" cy="3429000"/>
           </a:xfrm>
           <a:prstGeom xmlns:a="http://schemas.openxmlformats.org/drawingml/2006/main" prst="rect">
             <a:avLst/>
@@ -1754,71 +1720,10 @@
           <a:p xmlns:a="http://schemas.openxmlformats.org/drawingml/2006/main">
             <a:pPr algn="l">
               <a:lnSpc>
-                <a:spcPct val="100000"/>
-              </a:lnSpc>
-              <a:buNone/>
-              <a:defRPr sz="1950" b="1">
-                <a:solidFill>
-                  <a:srgbClr val="C8FF00"/>
-                </a:solidFill>
-                <a:latin typeface="Menlo"/>
-                <a:ea typeface="Menlo"/>
-                <a:cs typeface="Menlo"/>
-              </a:defRPr>
-            </a:pPr>
-            <a:r>
-              <a:rPr sz="1950" b="1">
-                <a:solidFill>
-                  <a:srgbClr val="C8FF00"/>
-                </a:solidFill>
-                <a:latin typeface="Menlo"/>
-                <a:ea typeface="Menlo"/>
-                <a:cs typeface="Menlo"/>
-              </a:rPr>
-              <a:t>TOOL CALLING</a:t>
-            </a:r>
-          </a:p>
-        </p:txBody>
-      </p:sp>
-      <p:sp>
-        <p:nvSpPr>
-          <p:cNvPr id="5" name="">
-            <a:extLst xmlns:a="http://schemas.openxmlformats.org/drawingml/2006/main">
-              <a:ext uri="{FF2B5EF4-FFF2-40B4-BE49-F238E27FC236}">
-                <a16:creationId xmlns:a16="http://schemas.microsoft.com/office/drawing/2014/main" id="{22CA0DFC-CF39-4E7D-9BEA-028F82DAFA56}"/>
-              </a:ext>
-            </a:extLst>
-          </p:cNvPr>
-          <p:cNvSpPr>
-            <a:spLocks xmlns:a="http://schemas.openxmlformats.org/drawingml/2006/main" noGrp="1"/>
-          </p:cNvSpPr>
-          <p:nvPr/>
-        </p:nvSpPr>
-        <p:spPr>
-          <a:xfrm xmlns:a="http://schemas.openxmlformats.org/drawingml/2006/main">
-            <a:off x="762000" y="1952625"/>
-            <a:ext cx="5810250" cy="3286125"/>
-          </a:xfrm>
-          <a:prstGeom xmlns:a="http://schemas.openxmlformats.org/drawingml/2006/main" prst="rect">
-            <a:avLst/>
-          </a:prstGeom>
-          <a:noFill xmlns:a="http://schemas.openxmlformats.org/drawingml/2006/main"/>
-          <a:ln xmlns:a="http://schemas.openxmlformats.org/drawingml/2006/main" w="0">
-            <a:noFill/>
-          </a:ln>
-        </p:spPr>
-        <p:txBody>
-          <a:bodyPr xmlns:a="http://schemas.openxmlformats.org/drawingml/2006/main" lIns="0" tIns="0" rIns="0" bIns="0" anchor="t">
-            <a:noAutofit/>
-          </a:bodyPr>
-          <a:lstStyle xmlns:a="http://schemas.openxmlformats.org/drawingml/2006/main"/>
-          <a:p xmlns:a="http://schemas.openxmlformats.org/drawingml/2006/main">
-            <a:pPr algn="l">
-              <a:lnSpc>
                 <a:spcPct val="90000"/>
               </a:lnSpc>
               <a:buNone/>
-              <a:defRPr sz="6825" b="1">
+              <a:defRPr sz="7800" b="1">
                 <a:solidFill>
                   <a:srgbClr val="F7F7F5"/>
                 </a:solidFill>
@@ -1828,7 +1733,7 @@
               </a:defRPr>
             </a:pPr>
             <a:r>
-              <a:rPr sz="6825" b="1">
+              <a:rPr sz="7800" b="1">
                 <a:solidFill>
                   <a:srgbClr val="F7F7F5"/>
                 </a:solidFill>
@@ -1845,7 +1750,7 @@
                 <a:spcPct val="90000"/>
               </a:lnSpc>
               <a:buNone/>
-              <a:defRPr sz="6825" b="1">
+              <a:defRPr sz="7800" b="1">
                 <a:solidFill>
                   <a:srgbClr val="F7F7F5"/>
                 </a:solidFill>
@@ -1855,7 +1760,7 @@
               </a:defRPr>
             </a:pPr>
             <a:r>
-              <a:rPr sz="6825" b="1">
+              <a:rPr sz="7800" b="1">
                 <a:solidFill>
                   <a:srgbClr val="F7F7F5"/>
                 </a:solidFill>
@@ -1863,29 +1768,40 @@
                 <a:ea typeface="Arial Black"/>
                 <a:cs typeface="Arial Black"/>
               </a:rPr>
-              <a:t>un solo parser</a:t>
-            </a:r>
-          </a:p>
-        </p:txBody>
-      </p:sp>
-      <p:sp>
-        <p:nvSpPr>
-          <p:cNvPr id="6" name="">
-            <a:extLst xmlns:a="http://schemas.openxmlformats.org/drawingml/2006/main">
-              <a:ext uri="{FF2B5EF4-FFF2-40B4-BE49-F238E27FC236}">
-                <a16:creationId xmlns:a16="http://schemas.microsoft.com/office/drawing/2014/main" id="{F1D30CBC-1AFA-40AC-9115-672942237335}"/>
-              </a:ext>
-            </a:extLst>
-          </p:cNvPr>
-          <p:cNvSpPr>
-            <a:spLocks xmlns:a="http://schemas.openxmlformats.org/drawingml/2006/main" noGrp="1"/>
-          </p:cNvSpPr>
-          <p:nvPr/>
-        </p:nvSpPr>
-        <p:spPr>
-          <a:xfrm xmlns:a="http://schemas.openxmlformats.org/drawingml/2006/main">
-            <a:off x="762000" y="5667375"/>
-            <a:ext cx="4953000" cy="1381125"/>
+              <a:t>un solo </a:t>
+            </a:r>
+            <a:r>
+              <a:rPr sz="7800" b="1">
+                <a:solidFill>
+                  <a:srgbClr val="C8FF00"/>
+                </a:solidFill>
+                <a:latin typeface="Arial Black"/>
+                <a:ea typeface="Arial Black"/>
+                <a:cs typeface="Arial Black"/>
+              </a:rPr>
+              <a:t>parser</a:t>
+            </a:r>
+          </a:p>
+        </p:txBody>
+      </p:sp>
+      <p:sp>
+        <p:nvSpPr>
+          <p:cNvPr id="3" name="">
+            <a:extLst xmlns:a="http://schemas.openxmlformats.org/drawingml/2006/main">
+              <a:ext uri="{FF2B5EF4-FFF2-40B4-BE49-F238E27FC236}">
+                <a16:creationId xmlns:a16="http://schemas.microsoft.com/office/drawing/2014/main" id="{224904C4-EFEE-4BFA-A1D0-D9F88CD63F17}"/>
+              </a:ext>
+            </a:extLst>
+          </p:cNvPr>
+          <p:cNvSpPr>
+            <a:spLocks xmlns:a="http://schemas.openxmlformats.org/drawingml/2006/main" noGrp="1"/>
+          </p:cNvSpPr>
+          <p:nvPr/>
+        </p:nvSpPr>
+        <p:spPr>
+          <a:xfrm xmlns:a="http://schemas.openxmlformats.org/drawingml/2006/main">
+            <a:off x="762000" y="6286500"/>
+            <a:ext cx="8382000" cy="1143000"/>
           </a:xfrm>
           <a:prstGeom xmlns:a="http://schemas.openxmlformats.org/drawingml/2006/main" prst="rect">
             <a:avLst/>
@@ -1906,7 +1822,7 @@
                 <a:spcPct val="110000"/>
               </a:lnSpc>
               <a:buNone/>
-              <a:defRPr sz="2700" b="0">
+              <a:defRPr sz="3000" b="0">
                 <a:solidFill>
                   <a:srgbClr val="A1A1AA"/>
                 </a:solidFill>
@@ -1916,7 +1832,7 @@
               </a:defRPr>
             </a:pPr>
             <a:r>
-              <a:rPr sz="2700" b="0">
+              <a:rPr sz="3000" b="0">
                 <a:solidFill>
                   <a:srgbClr val="A1A1AA"/>
                 </a:solidFill>
@@ -1931,52 +1847,22 @@
       </p:sp>
       <p:sp>
         <p:nvSpPr>
-          <p:cNvPr id="7" name="">
-            <a:extLst xmlns:a="http://schemas.openxmlformats.org/drawingml/2006/main">
-              <a:ext uri="{FF2B5EF4-FFF2-40B4-BE49-F238E27FC236}">
-                <a16:creationId xmlns:a16="http://schemas.microsoft.com/office/drawing/2014/main" id="{E486BBDA-89CF-4040-A57A-9271D030A324}"/>
-              </a:ext>
-            </a:extLst>
-          </p:cNvPr>
-          <p:cNvSpPr>
-            <a:spLocks xmlns:a="http://schemas.openxmlformats.org/drawingml/2006/main" noGrp="1"/>
-          </p:cNvSpPr>
-          <p:nvPr/>
-        </p:nvSpPr>
-        <p:spPr>
-          <a:xfrm xmlns:a="http://schemas.openxmlformats.org/drawingml/2006/main">
-            <a:off x="762000" y="7667625"/>
-            <a:ext cx="2857500" cy="0"/>
-          </a:xfrm>
-          <a:prstGeom xmlns:a="http://schemas.openxmlformats.org/drawingml/2006/main" prst="line">
-            <a:avLst/>
-          </a:prstGeom>
-          <a:noFill xmlns:a="http://schemas.openxmlformats.org/drawingml/2006/main"/>
-          <a:ln xmlns:a="http://schemas.openxmlformats.org/drawingml/2006/main" w="76200">
-            <a:solidFill>
-              <a:srgbClr val="C8FF00"/>
-            </a:solidFill>
-          </a:ln>
-        </p:spPr>
-      </p:sp>
-      <p:sp>
-        <p:nvSpPr>
-          <p:cNvPr id="8" name="">
-            <a:extLst xmlns:a="http://schemas.openxmlformats.org/drawingml/2006/main">
-              <a:ext uri="{FF2B5EF4-FFF2-40B4-BE49-F238E27FC236}">
-                <a16:creationId xmlns:a16="http://schemas.microsoft.com/office/drawing/2014/main" id="{13B82226-1E13-4B1F-8D98-B3F013F32C68}"/>
-              </a:ext>
-            </a:extLst>
-          </p:cNvPr>
-          <p:cNvSpPr>
-            <a:spLocks xmlns:a="http://schemas.openxmlformats.org/drawingml/2006/main" noGrp="1"/>
-          </p:cNvSpPr>
-          <p:nvPr/>
-        </p:nvSpPr>
-        <p:spPr>
-          <a:xfrm xmlns:a="http://schemas.openxmlformats.org/drawingml/2006/main">
-            <a:off x="762000" y="8096250"/>
-            <a:ext cx="4762500" cy="857250"/>
+          <p:cNvPr id="4" name="">
+            <a:extLst xmlns:a="http://schemas.openxmlformats.org/drawingml/2006/main">
+              <a:ext uri="{FF2B5EF4-FFF2-40B4-BE49-F238E27FC236}">
+                <a16:creationId xmlns:a16="http://schemas.microsoft.com/office/drawing/2014/main" id="{CC6EB071-C9E7-4318-A3E5-0504D6FFD8C4}"/>
+              </a:ext>
+            </a:extLst>
+          </p:cNvPr>
+          <p:cNvSpPr>
+            <a:spLocks xmlns:a="http://schemas.openxmlformats.org/drawingml/2006/main" noGrp="1"/>
+          </p:cNvSpPr>
+          <p:nvPr/>
+        </p:nvSpPr>
+        <p:spPr>
+          <a:xfrm xmlns:a="http://schemas.openxmlformats.org/drawingml/2006/main">
+            <a:off x="762000" y="8572500"/>
+            <a:ext cx="6667500" cy="952500"/>
           </a:xfrm>
           <a:prstGeom xmlns:a="http://schemas.openxmlformats.org/drawingml/2006/main" prst="rect">
             <a:avLst/>
@@ -1997,7 +1883,7 @@
                 <a:spcPct val="100000"/>
               </a:lnSpc>
               <a:buNone/>
-              <a:defRPr sz="1950" b="1">
+              <a:defRPr sz="2175" b="1">
                 <a:solidFill>
                   <a:srgbClr val="F7F7F5"/>
                 </a:solidFill>
@@ -2007,7 +1893,7 @@
               </a:defRPr>
             </a:pPr>
             <a:r>
-              <a:rPr sz="1950" b="1">
+              <a:rPr sz="2175" b="1">
                 <a:solidFill>
                   <a:srgbClr val="F7F7F5"/>
                 </a:solidFill>
@@ -2024,7 +1910,7 @@
                 <a:spcPct val="100000"/>
               </a:lnSpc>
               <a:buNone/>
-              <a:defRPr sz="1950" b="1">
+              <a:defRPr sz="2175" b="1">
                 <a:solidFill>
                   <a:srgbClr val="F7F7F5"/>
                 </a:solidFill>
@@ -2034,7 +1920,7 @@
               </a:defRPr>
             </a:pPr>
             <a:r>
-              <a:rPr sz="1950" b="1">
+              <a:rPr sz="2175" b="1">
                 <a:solidFill>
                   <a:srgbClr val="F7F7F5"/>
                 </a:solidFill>
@@ -2049,22 +1935,22 @@
       </p:sp>
       <p:sp>
         <p:nvSpPr>
-          <p:cNvPr id="9" name="">
-            <a:extLst xmlns:a="http://schemas.openxmlformats.org/drawingml/2006/main">
-              <a:ext uri="{FF2B5EF4-FFF2-40B4-BE49-F238E27FC236}">
-                <a16:creationId xmlns:a16="http://schemas.microsoft.com/office/drawing/2014/main" id="{E727C0F3-5BB3-4847-920E-BC1F16DDF574}"/>
-              </a:ext>
-            </a:extLst>
-          </p:cNvPr>
-          <p:cNvSpPr>
-            <a:spLocks xmlns:a="http://schemas.openxmlformats.org/drawingml/2006/main" noGrp="1"/>
-          </p:cNvSpPr>
-          <p:nvPr/>
-        </p:nvSpPr>
-        <p:spPr>
-          <a:xfrm xmlns:a="http://schemas.openxmlformats.org/drawingml/2006/main">
-            <a:off x="762000" y="11144250"/>
-            <a:ext cx="4762500" cy="666750"/>
+          <p:cNvPr id="5" name="">
+            <a:extLst xmlns:a="http://schemas.openxmlformats.org/drawingml/2006/main">
+              <a:ext uri="{FF2B5EF4-FFF2-40B4-BE49-F238E27FC236}">
+                <a16:creationId xmlns:a16="http://schemas.microsoft.com/office/drawing/2014/main" id="{5349E690-531A-4542-A7A0-11837DC528DD}"/>
+              </a:ext>
+            </a:extLst>
+          </p:cNvPr>
+          <p:cNvSpPr>
+            <a:spLocks xmlns:a="http://schemas.openxmlformats.org/drawingml/2006/main" noGrp="1"/>
+          </p:cNvSpPr>
+          <p:nvPr/>
+        </p:nvSpPr>
+        <p:spPr>
+          <a:xfrm xmlns:a="http://schemas.openxmlformats.org/drawingml/2006/main">
+            <a:off x="762000" y="11096625"/>
+            <a:ext cx="7239000" cy="666750"/>
           </a:xfrm>
           <a:prstGeom xmlns:a="http://schemas.openxmlformats.org/drawingml/2006/main" prst="rect">
             <a:avLst/>
@@ -2085,7 +1971,7 @@
                 <a:spcPct val="100000"/>
               </a:lnSpc>
               <a:buNone/>
-              <a:defRPr sz="2025" b="0">
+              <a:defRPr sz="2100" b="0">
                 <a:solidFill>
                   <a:srgbClr val="A1A1AA"/>
                 </a:solidFill>
@@ -2095,7 +1981,7 @@
               </a:defRPr>
             </a:pPr>
             <a:r>
-              <a:rPr sz="2025" b="0">
+              <a:rPr sz="2100" b="0">
                 <a:solidFill>
                   <a:srgbClr val="A1A1AA"/>
                 </a:solidFill>
@@ -2110,10 +1996,10 @@
       </p:sp>
       <p:sp>
         <p:nvSpPr>
-          <p:cNvPr id="10" name="">
-            <a:extLst xmlns:a="http://schemas.openxmlformats.org/drawingml/2006/main">
-              <a:ext uri="{FF2B5EF4-FFF2-40B4-BE49-F238E27FC236}">
-                <a16:creationId xmlns:a16="http://schemas.microsoft.com/office/drawing/2014/main" id="{B04B7FB3-F76D-44BB-840B-3AA00ED439B9}"/>
+          <p:cNvPr id="6" name="">
+            <a:extLst xmlns:a="http://schemas.openxmlformats.org/drawingml/2006/main">
+              <a:ext uri="{FF2B5EF4-FFF2-40B4-BE49-F238E27FC236}">
+                <a16:creationId xmlns:a16="http://schemas.microsoft.com/office/drawing/2014/main" id="{F0B6F713-42B6-4D13-AC39-7942CD7A14D6}"/>
               </a:ext>
             </a:extLst>
           </p:cNvPr>
@@ -2172,7 +2058,7 @@
     </p:spTree>
     <p:extLst>
       <p:ext uri="{BB962C8B-B14F-4D97-AF65-F5344CB8AC3E}">
-        <p14:creationId xmlns:p14="http://schemas.microsoft.com/office/powerpoint/2010/main" val="1157731464"/>
+        <p14:creationId xmlns:p14="http://schemas.microsoft.com/office/powerpoint/2010/main" val="988454441"/>
       </p:ext>
     </p:extLst>
   </p:cSld>
@@ -2203,7 +2089,7 @@
           <p:cNvPr id="21" name="">
             <a:extLst xmlns:a="http://schemas.openxmlformats.org/drawingml/2006/main">
               <a:ext uri="{FF2B5EF4-FFF2-40B4-BE49-F238E27FC236}">
-                <a16:creationId xmlns:a16="http://schemas.microsoft.com/office/drawing/2014/main" id="{099B8F2E-1E5C-403F-9B66-CD00AF7D08CC}"/>
+                <a16:creationId xmlns:a16="http://schemas.microsoft.com/office/drawing/2014/main" id="{8C842DD6-3301-47BF-9468-0174509E1EBA}"/>
               </a:ext>
             </a:extLst>
           </p:cNvPr>
@@ -2233,7 +2119,7 @@
           <p:cNvPr id="2" name="">
             <a:extLst xmlns:a="http://schemas.openxmlformats.org/drawingml/2006/main">
               <a:ext uri="{FF2B5EF4-FFF2-40B4-BE49-F238E27FC236}">
-                <a16:creationId xmlns:a16="http://schemas.microsoft.com/office/drawing/2014/main" id="{95B28411-8C5D-490F-A123-72B4B0120026}"/>
+                <a16:creationId xmlns:a16="http://schemas.microsoft.com/office/drawing/2014/main" id="{4D511094-C9CA-4AF7-8B26-A802DAC3E1E3}"/>
               </a:ext>
             </a:extLst>
           </p:cNvPr>
@@ -2294,7 +2180,7 @@
           <p:cNvPr id="3" name="">
             <a:extLst xmlns:a="http://schemas.openxmlformats.org/drawingml/2006/main">
               <a:ext uri="{FF2B5EF4-FFF2-40B4-BE49-F238E27FC236}">
-                <a16:creationId xmlns:a16="http://schemas.microsoft.com/office/drawing/2014/main" id="{5B4EBAC0-8684-44D7-8088-6C53CFBA38D2}"/>
+                <a16:creationId xmlns:a16="http://schemas.microsoft.com/office/drawing/2014/main" id="{9B8E0F2D-9899-4FDC-BBDB-482770950036}"/>
               </a:ext>
             </a:extLst>
           </p:cNvPr>
@@ -2382,7 +2268,7 @@
           <p:cNvPr id="4" name="">
             <a:extLst xmlns:a="http://schemas.openxmlformats.org/drawingml/2006/main">
               <a:ext uri="{FF2B5EF4-FFF2-40B4-BE49-F238E27FC236}">
-                <a16:creationId xmlns:a16="http://schemas.microsoft.com/office/drawing/2014/main" id="{73A3A00B-0DB6-4198-8C21-206F412B8E0C}"/>
+                <a16:creationId xmlns:a16="http://schemas.microsoft.com/office/drawing/2014/main" id="{16D8D18D-56E3-4A45-A946-4DD25E703A48}"/>
               </a:ext>
             </a:extLst>
           </p:cNvPr>
@@ -2443,7 +2329,7 @@
           <p:cNvPr id="5" name="">
             <a:extLst xmlns:a="http://schemas.openxmlformats.org/drawingml/2006/main">
               <a:ext uri="{FF2B5EF4-FFF2-40B4-BE49-F238E27FC236}">
-                <a16:creationId xmlns:a16="http://schemas.microsoft.com/office/drawing/2014/main" id="{58D0BBBD-633B-4D3B-A235-14E616D8BEF2}"/>
+                <a16:creationId xmlns:a16="http://schemas.microsoft.com/office/drawing/2014/main" id="{164D3471-B439-4103-A3B3-C2DD0CB5C359}"/>
               </a:ext>
             </a:extLst>
           </p:cNvPr>
@@ -2504,7 +2390,7 @@
           <p:cNvPr id="6" name="">
             <a:extLst xmlns:a="http://schemas.openxmlformats.org/drawingml/2006/main">
               <a:ext uri="{FF2B5EF4-FFF2-40B4-BE49-F238E27FC236}">
-                <a16:creationId xmlns:a16="http://schemas.microsoft.com/office/drawing/2014/main" id="{1AE03FF3-0EFE-413C-9F79-AAD676D486D6}"/>
+                <a16:creationId xmlns:a16="http://schemas.microsoft.com/office/drawing/2014/main" id="{635A9627-7476-45ED-925A-69AE6A914578}"/>
               </a:ext>
             </a:extLst>
           </p:cNvPr>
@@ -2565,7 +2451,7 @@
           <p:cNvPr id="7" name="">
             <a:extLst xmlns:a="http://schemas.openxmlformats.org/drawingml/2006/main">
               <a:ext uri="{FF2B5EF4-FFF2-40B4-BE49-F238E27FC236}">
-                <a16:creationId xmlns:a16="http://schemas.microsoft.com/office/drawing/2014/main" id="{1BD22E75-547B-4D26-BEB7-79C675DBDD90}"/>
+                <a16:creationId xmlns:a16="http://schemas.microsoft.com/office/drawing/2014/main" id="{D1C05117-B654-406C-BFBC-9699792F3831}"/>
               </a:ext>
             </a:extLst>
           </p:cNvPr>
@@ -2626,7 +2512,7 @@
           <p:cNvPr id="8" name="">
             <a:extLst xmlns:a="http://schemas.openxmlformats.org/drawingml/2006/main">
               <a:ext uri="{FF2B5EF4-FFF2-40B4-BE49-F238E27FC236}">
-                <a16:creationId xmlns:a16="http://schemas.microsoft.com/office/drawing/2014/main" id="{B32BCE73-43F2-4980-AEAD-D5D5C04BC5E9}"/>
+                <a16:creationId xmlns:a16="http://schemas.microsoft.com/office/drawing/2014/main" id="{9DCDDA5E-A723-44A7-A4C4-07831088ABD1}"/>
               </a:ext>
             </a:extLst>
           </p:cNvPr>
@@ -2656,7 +2542,7 @@
           <p:cNvPr id="9" name="">
             <a:extLst xmlns:a="http://schemas.openxmlformats.org/drawingml/2006/main">
               <a:ext uri="{FF2B5EF4-FFF2-40B4-BE49-F238E27FC236}">
-                <a16:creationId xmlns:a16="http://schemas.microsoft.com/office/drawing/2014/main" id="{C1162154-C0DF-4449-898C-64FDCEB3BFFD}"/>
+                <a16:creationId xmlns:a16="http://schemas.microsoft.com/office/drawing/2014/main" id="{5B5F95CA-DE15-4879-9800-7CC565727C8C}"/>
               </a:ext>
             </a:extLst>
           </p:cNvPr>
@@ -2717,7 +2603,7 @@
           <p:cNvPr id="10" name="">
             <a:extLst xmlns:a="http://schemas.openxmlformats.org/drawingml/2006/main">
               <a:ext uri="{FF2B5EF4-FFF2-40B4-BE49-F238E27FC236}">
-                <a16:creationId xmlns:a16="http://schemas.microsoft.com/office/drawing/2014/main" id="{FE66A85C-DCE8-4E72-B8DB-6DFCC31C5B0E}"/>
+                <a16:creationId xmlns:a16="http://schemas.microsoft.com/office/drawing/2014/main" id="{72605B10-15FD-43AC-B5CF-8ECA1463F780}"/>
               </a:ext>
             </a:extLst>
           </p:cNvPr>
@@ -2778,7 +2664,7 @@
           <p:cNvPr id="11" name="">
             <a:extLst xmlns:a="http://schemas.openxmlformats.org/drawingml/2006/main">
               <a:ext uri="{FF2B5EF4-FFF2-40B4-BE49-F238E27FC236}">
-                <a16:creationId xmlns:a16="http://schemas.microsoft.com/office/drawing/2014/main" id="{AC298196-82BD-476D-AD3E-CC41779E377A}"/>
+                <a16:creationId xmlns:a16="http://schemas.microsoft.com/office/drawing/2014/main" id="{E18BB312-1D8A-4FD5-8B65-CD95287F36E8}"/>
               </a:ext>
             </a:extLst>
           </p:cNvPr>
@@ -2839,7 +2725,7 @@
           <p:cNvPr id="12" name="">
             <a:extLst xmlns:a="http://schemas.openxmlformats.org/drawingml/2006/main">
               <a:ext uri="{FF2B5EF4-FFF2-40B4-BE49-F238E27FC236}">
-                <a16:creationId xmlns:a16="http://schemas.microsoft.com/office/drawing/2014/main" id="{4D82BD9D-2990-4F28-8CBB-0DE8C5AF16D7}"/>
+                <a16:creationId xmlns:a16="http://schemas.microsoft.com/office/drawing/2014/main" id="{8866285F-56E0-4F3F-A95A-4A0C95C68637}"/>
               </a:ext>
             </a:extLst>
           </p:cNvPr>
@@ -2900,7 +2786,7 @@
           <p:cNvPr id="13" name="">
             <a:extLst xmlns:a="http://schemas.openxmlformats.org/drawingml/2006/main">
               <a:ext uri="{FF2B5EF4-FFF2-40B4-BE49-F238E27FC236}">
-                <a16:creationId xmlns:a16="http://schemas.microsoft.com/office/drawing/2014/main" id="{36CA6232-7E80-4EF6-BC3A-560E1D810E90}"/>
+                <a16:creationId xmlns:a16="http://schemas.microsoft.com/office/drawing/2014/main" id="{A8AF415D-80E6-4EB6-9D6C-7CCC8636E0D2}"/>
               </a:ext>
             </a:extLst>
           </p:cNvPr>
@@ -2930,7 +2816,7 @@
           <p:cNvPr id="14" name="">
             <a:extLst xmlns:a="http://schemas.openxmlformats.org/drawingml/2006/main">
               <a:ext uri="{FF2B5EF4-FFF2-40B4-BE49-F238E27FC236}">
-                <a16:creationId xmlns:a16="http://schemas.microsoft.com/office/drawing/2014/main" id="{E7F07C20-588A-456E-BEE0-94363195CACD}"/>
+                <a16:creationId xmlns:a16="http://schemas.microsoft.com/office/drawing/2014/main" id="{CE7D31A3-FB9B-472C-89F6-B44736C7E392}"/>
               </a:ext>
             </a:extLst>
           </p:cNvPr>
@@ -2991,7 +2877,7 @@
           <p:cNvPr id="15" name="">
             <a:extLst xmlns:a="http://schemas.openxmlformats.org/drawingml/2006/main">
               <a:ext uri="{FF2B5EF4-FFF2-40B4-BE49-F238E27FC236}">
-                <a16:creationId xmlns:a16="http://schemas.microsoft.com/office/drawing/2014/main" id="{0F0E2D90-8F6C-4A2E-8D05-0AB414F0D9FF}"/>
+                <a16:creationId xmlns:a16="http://schemas.microsoft.com/office/drawing/2014/main" id="{7818EB6F-1A08-44DF-A4C7-6A95F923E8A7}"/>
               </a:ext>
             </a:extLst>
           </p:cNvPr>
@@ -3052,7 +2938,7 @@
           <p:cNvPr id="16" name="">
             <a:extLst xmlns:a="http://schemas.openxmlformats.org/drawingml/2006/main">
               <a:ext uri="{FF2B5EF4-FFF2-40B4-BE49-F238E27FC236}">
-                <a16:creationId xmlns:a16="http://schemas.microsoft.com/office/drawing/2014/main" id="{69754318-0F15-40BD-9006-B20E2419FE09}"/>
+                <a16:creationId xmlns:a16="http://schemas.microsoft.com/office/drawing/2014/main" id="{1C46FA1A-2977-4DFC-88D2-15E29D75A0B0}"/>
               </a:ext>
             </a:extLst>
           </p:cNvPr>
@@ -3113,7 +2999,7 @@
           <p:cNvPr id="17" name="">
             <a:extLst xmlns:a="http://schemas.openxmlformats.org/drawingml/2006/main">
               <a:ext uri="{FF2B5EF4-FFF2-40B4-BE49-F238E27FC236}">
-                <a16:creationId xmlns:a16="http://schemas.microsoft.com/office/drawing/2014/main" id="{2D583FDF-9212-4386-AD41-4EB86421D0CA}"/>
+                <a16:creationId xmlns:a16="http://schemas.microsoft.com/office/drawing/2014/main" id="{B0F603B4-7AFC-4974-8033-28822426FBF6}"/>
               </a:ext>
             </a:extLst>
           </p:cNvPr>
@@ -3174,7 +3060,7 @@
           <p:cNvPr id="18" name="">
             <a:extLst xmlns:a="http://schemas.openxmlformats.org/drawingml/2006/main">
               <a:ext uri="{FF2B5EF4-FFF2-40B4-BE49-F238E27FC236}">
-                <a16:creationId xmlns:a16="http://schemas.microsoft.com/office/drawing/2014/main" id="{895F9DAA-CF8A-4E79-BEC9-487872E5B5F8}"/>
+                <a16:creationId xmlns:a16="http://schemas.microsoft.com/office/drawing/2014/main" id="{4CFD7FD8-D282-4B6D-953F-D0A6D8A6E957}"/>
               </a:ext>
             </a:extLst>
           </p:cNvPr>
@@ -3204,7 +3090,7 @@
           <p:cNvPr id="19" name="">
             <a:extLst xmlns:a="http://schemas.openxmlformats.org/drawingml/2006/main">
               <a:ext uri="{FF2B5EF4-FFF2-40B4-BE49-F238E27FC236}">
-                <a16:creationId xmlns:a16="http://schemas.microsoft.com/office/drawing/2014/main" id="{97615867-51E3-418D-ABA7-21D43375ABF7}"/>
+                <a16:creationId xmlns:a16="http://schemas.microsoft.com/office/drawing/2014/main" id="{085562C4-0B36-4D30-AA2F-9931BB415302}"/>
               </a:ext>
             </a:extLst>
           </p:cNvPr>
@@ -3265,7 +3151,7 @@
           <p:cNvPr id="20" name="">
             <a:extLst xmlns:a="http://schemas.openxmlformats.org/drawingml/2006/main">
               <a:ext uri="{FF2B5EF4-FFF2-40B4-BE49-F238E27FC236}">
-                <a16:creationId xmlns:a16="http://schemas.microsoft.com/office/drawing/2014/main" id="{94897BCC-E4D7-4D09-91B8-685EFBF700C4}"/>
+                <a16:creationId xmlns:a16="http://schemas.microsoft.com/office/drawing/2014/main" id="{EE3F91BB-7527-4A99-991A-B91A670C39A2}"/>
               </a:ext>
             </a:extLst>
           </p:cNvPr>
@@ -3324,7 +3210,7 @@
     </p:spTree>
     <p:extLst>
       <p:ext uri="{BB962C8B-B14F-4D97-AF65-F5344CB8AC3E}">
-        <p14:creationId xmlns:p14="http://schemas.microsoft.com/office/powerpoint/2010/main" val="936320483"/>
+        <p14:creationId xmlns:p14="http://schemas.microsoft.com/office/powerpoint/2010/main" val="1722286840"/>
       </p:ext>
     </p:extLst>
   </p:cSld>
@@ -3355,7 +3241,7 @@
           <p:cNvPr id="17" name="">
             <a:extLst xmlns:a="http://schemas.openxmlformats.org/drawingml/2006/main">
               <a:ext uri="{FF2B5EF4-FFF2-40B4-BE49-F238E27FC236}">
-                <a16:creationId xmlns:a16="http://schemas.microsoft.com/office/drawing/2014/main" id="{29EBFB95-849C-4281-88E3-171731354C93}"/>
+                <a16:creationId xmlns:a16="http://schemas.microsoft.com/office/drawing/2014/main" id="{0588F85A-BC00-4415-8B37-35BA0EAA2E94}"/>
               </a:ext>
             </a:extLst>
           </p:cNvPr>
@@ -3385,7 +3271,7 @@
           <p:cNvPr id="2" name="">
             <a:extLst xmlns:a="http://schemas.openxmlformats.org/drawingml/2006/main">
               <a:ext uri="{FF2B5EF4-FFF2-40B4-BE49-F238E27FC236}">
-                <a16:creationId xmlns:a16="http://schemas.microsoft.com/office/drawing/2014/main" id="{657A9B2B-22B5-4AAC-A2FA-359ABC8CE64F}"/>
+                <a16:creationId xmlns:a16="http://schemas.microsoft.com/office/drawing/2014/main" id="{FC238F02-3784-4C52-8586-AF7342BF3021}"/>
               </a:ext>
             </a:extLst>
           </p:cNvPr>
@@ -3446,7 +3332,7 @@
           <p:cNvPr id="3" name="">
             <a:extLst xmlns:a="http://schemas.openxmlformats.org/drawingml/2006/main">
               <a:ext uri="{FF2B5EF4-FFF2-40B4-BE49-F238E27FC236}">
-                <a16:creationId xmlns:a16="http://schemas.microsoft.com/office/drawing/2014/main" id="{AB850C90-F233-474D-8E8F-BD7647A9EA08}"/>
+                <a16:creationId xmlns:a16="http://schemas.microsoft.com/office/drawing/2014/main" id="{A64EC337-ECC9-4D00-B140-58BEE4296E31}"/>
               </a:ext>
             </a:extLst>
           </p:cNvPr>
@@ -3518,7 +3404,7 @@
           <p:cNvPr id="4" name="">
             <a:extLst xmlns:a="http://schemas.openxmlformats.org/drawingml/2006/main">
               <a:ext uri="{FF2B5EF4-FFF2-40B4-BE49-F238E27FC236}">
-                <a16:creationId xmlns:a16="http://schemas.microsoft.com/office/drawing/2014/main" id="{633CAAFE-0A3B-4486-80C2-AC1EF234BE53}"/>
+                <a16:creationId xmlns:a16="http://schemas.microsoft.com/office/drawing/2014/main" id="{EE0227B8-92BE-4E3A-9BDE-DC27DA5A8181}"/>
               </a:ext>
             </a:extLst>
           </p:cNvPr>
@@ -3552,7 +3438,7 @@
           <p:cNvPr id="5" name="">
             <a:extLst xmlns:a="http://schemas.openxmlformats.org/drawingml/2006/main">
               <a:ext uri="{FF2B5EF4-FFF2-40B4-BE49-F238E27FC236}">
-                <a16:creationId xmlns:a16="http://schemas.microsoft.com/office/drawing/2014/main" id="{5F2DC7A5-9CDC-4305-8CB0-6756BBFF28CF}"/>
+                <a16:creationId xmlns:a16="http://schemas.microsoft.com/office/drawing/2014/main" id="{9E4B97DA-EEC8-4136-BF8B-D64607CEE42A}"/>
               </a:ext>
             </a:extLst>
           </p:cNvPr>
@@ -3613,7 +3499,7 @@
           <p:cNvPr id="6" name="">
             <a:extLst xmlns:a="http://schemas.openxmlformats.org/drawingml/2006/main">
               <a:ext uri="{FF2B5EF4-FFF2-40B4-BE49-F238E27FC236}">
-                <a16:creationId xmlns:a16="http://schemas.microsoft.com/office/drawing/2014/main" id="{F50C39D1-9BF6-450F-A026-731A935DAC2F}"/>
+                <a16:creationId xmlns:a16="http://schemas.microsoft.com/office/drawing/2014/main" id="{0B9D38D2-6643-4051-8648-78D0AB77B8FC}"/>
               </a:ext>
             </a:extLst>
           </p:cNvPr>
@@ -3674,7 +3560,7 @@
           <p:cNvPr id="7" name="">
             <a:extLst xmlns:a="http://schemas.openxmlformats.org/drawingml/2006/main">
               <a:ext uri="{FF2B5EF4-FFF2-40B4-BE49-F238E27FC236}">
-                <a16:creationId xmlns:a16="http://schemas.microsoft.com/office/drawing/2014/main" id="{EDDB0766-9E28-4ADC-B775-A330B2F8C4B0}"/>
+                <a16:creationId xmlns:a16="http://schemas.microsoft.com/office/drawing/2014/main" id="{DDE381BF-8779-4CA1-AEE5-8565E623DD68}"/>
               </a:ext>
             </a:extLst>
           </p:cNvPr>
@@ -3735,7 +3621,7 @@
           <p:cNvPr id="8" name="">
             <a:extLst xmlns:a="http://schemas.openxmlformats.org/drawingml/2006/main">
               <a:ext uri="{FF2B5EF4-FFF2-40B4-BE49-F238E27FC236}">
-                <a16:creationId xmlns:a16="http://schemas.microsoft.com/office/drawing/2014/main" id="{651D0CD0-458B-4C6F-800A-56200929AF92}"/>
+                <a16:creationId xmlns:a16="http://schemas.microsoft.com/office/drawing/2014/main" id="{7DF9D78F-512F-48E5-89F4-1F1C310CE6E2}"/>
               </a:ext>
             </a:extLst>
           </p:cNvPr>
@@ -3796,7 +3682,7 @@
           <p:cNvPr id="9" name="">
             <a:extLst xmlns:a="http://schemas.openxmlformats.org/drawingml/2006/main">
               <a:ext uri="{FF2B5EF4-FFF2-40B4-BE49-F238E27FC236}">
-                <a16:creationId xmlns:a16="http://schemas.microsoft.com/office/drawing/2014/main" id="{367D5DB9-E863-40E8-8C77-FB4BCA5F3B79}"/>
+                <a16:creationId xmlns:a16="http://schemas.microsoft.com/office/drawing/2014/main" id="{0A3A5C88-4F9E-48C7-BFBE-67A8DC30BEFF}"/>
               </a:ext>
             </a:extLst>
           </p:cNvPr>
@@ -3857,7 +3743,7 @@
           <p:cNvPr id="10" name="">
             <a:extLst xmlns:a="http://schemas.openxmlformats.org/drawingml/2006/main">
               <a:ext uri="{FF2B5EF4-FFF2-40B4-BE49-F238E27FC236}">
-                <a16:creationId xmlns:a16="http://schemas.microsoft.com/office/drawing/2014/main" id="{79AB410B-7B1E-497D-9B03-7257F891F19F}"/>
+                <a16:creationId xmlns:a16="http://schemas.microsoft.com/office/drawing/2014/main" id="{8AEB86DB-794C-4B18-B757-D0FEF33BAEEA}"/>
               </a:ext>
             </a:extLst>
           </p:cNvPr>
@@ -3918,7 +3804,7 @@
           <p:cNvPr id="11" name="">
             <a:extLst xmlns:a="http://schemas.openxmlformats.org/drawingml/2006/main">
               <a:ext uri="{FF2B5EF4-FFF2-40B4-BE49-F238E27FC236}">
-                <a16:creationId xmlns:a16="http://schemas.microsoft.com/office/drawing/2014/main" id="{B61F1402-6A40-4B7A-A386-BF5D5BC38EA3}"/>
+                <a16:creationId xmlns:a16="http://schemas.microsoft.com/office/drawing/2014/main" id="{DA2EA55C-6E1E-42F9-B067-42422DA46842}"/>
               </a:ext>
             </a:extLst>
           </p:cNvPr>
@@ -3979,7 +3865,7 @@
           <p:cNvPr id="12" name="">
             <a:extLst xmlns:a="http://schemas.openxmlformats.org/drawingml/2006/main">
               <a:ext uri="{FF2B5EF4-FFF2-40B4-BE49-F238E27FC236}">
-                <a16:creationId xmlns:a16="http://schemas.microsoft.com/office/drawing/2014/main" id="{EA3B8CC6-0466-4F23-8C93-ED1625527F92}"/>
+                <a16:creationId xmlns:a16="http://schemas.microsoft.com/office/drawing/2014/main" id="{69A8350E-CCB8-4AD3-A15F-0BD97400943C}"/>
               </a:ext>
             </a:extLst>
           </p:cNvPr>
@@ -4040,7 +3926,7 @@
           <p:cNvPr id="13" name="">
             <a:extLst xmlns:a="http://schemas.openxmlformats.org/drawingml/2006/main">
               <a:ext uri="{FF2B5EF4-FFF2-40B4-BE49-F238E27FC236}">
-                <a16:creationId xmlns:a16="http://schemas.microsoft.com/office/drawing/2014/main" id="{877E676B-7165-4735-B687-D7FE31DBB783}"/>
+                <a16:creationId xmlns:a16="http://schemas.microsoft.com/office/drawing/2014/main" id="{BF1194C4-42FF-46F8-8D39-7E7EC318868F}"/>
               </a:ext>
             </a:extLst>
           </p:cNvPr>
@@ -4128,7 +4014,7 @@
           <p:cNvPr id="14" name="">
             <a:extLst xmlns:a="http://schemas.openxmlformats.org/drawingml/2006/main">
               <a:ext uri="{FF2B5EF4-FFF2-40B4-BE49-F238E27FC236}">
-                <a16:creationId xmlns:a16="http://schemas.microsoft.com/office/drawing/2014/main" id="{E110E84D-7190-4070-A2CF-BCCBD38AE7A1}"/>
+                <a16:creationId xmlns:a16="http://schemas.microsoft.com/office/drawing/2014/main" id="{42FCEE2E-986B-48BB-85C1-25625A1C80E5}"/>
               </a:ext>
             </a:extLst>
           </p:cNvPr>
@@ -4189,7 +4075,7 @@
           <p:cNvPr id="15" name="">
             <a:extLst xmlns:a="http://schemas.openxmlformats.org/drawingml/2006/main">
               <a:ext uri="{FF2B5EF4-FFF2-40B4-BE49-F238E27FC236}">
-                <a16:creationId xmlns:a16="http://schemas.microsoft.com/office/drawing/2014/main" id="{2CC7168D-C7AC-469E-ADF0-37EE8F2002E1}"/>
+                <a16:creationId xmlns:a16="http://schemas.microsoft.com/office/drawing/2014/main" id="{E8B7B4B5-1947-4445-AF58-50DA4AF854B6}"/>
               </a:ext>
             </a:extLst>
           </p:cNvPr>
@@ -4250,7 +4136,7 @@
           <p:cNvPr id="16" name="">
             <a:extLst xmlns:a="http://schemas.openxmlformats.org/drawingml/2006/main">
               <a:ext uri="{FF2B5EF4-FFF2-40B4-BE49-F238E27FC236}">
-                <a16:creationId xmlns:a16="http://schemas.microsoft.com/office/drawing/2014/main" id="{252E8A11-8815-4F8C-811C-152DC06CD74B}"/>
+                <a16:creationId xmlns:a16="http://schemas.microsoft.com/office/drawing/2014/main" id="{413B0967-3FBF-473F-A4C9-991D7EAF1C00}"/>
               </a:ext>
             </a:extLst>
           </p:cNvPr>
@@ -4309,7 +4195,7 @@
     </p:spTree>
     <p:extLst>
       <p:ext uri="{BB962C8B-B14F-4D97-AF65-F5344CB8AC3E}">
-        <p14:creationId xmlns:p14="http://schemas.microsoft.com/office/powerpoint/2010/main" val="279853764"/>
+        <p14:creationId xmlns:p14="http://schemas.microsoft.com/office/powerpoint/2010/main" val="1555765505"/>
       </p:ext>
     </p:extLst>
   </p:cSld>
@@ -4340,7 +4226,7 @@
           <p:cNvPr id="16" name="">
             <a:extLst xmlns:a="http://schemas.openxmlformats.org/drawingml/2006/main">
               <a:ext uri="{FF2B5EF4-FFF2-40B4-BE49-F238E27FC236}">
-                <a16:creationId xmlns:a16="http://schemas.microsoft.com/office/drawing/2014/main" id="{C03F02CF-21D9-44E2-986A-9C425FB745BD}"/>
+                <a16:creationId xmlns:a16="http://schemas.microsoft.com/office/drawing/2014/main" id="{B5BCBA77-91E2-46C5-AE3B-9E9108765D49}"/>
               </a:ext>
             </a:extLst>
           </p:cNvPr>
@@ -4370,7 +4256,7 @@
           <p:cNvPr id="2" name="">
             <a:extLst xmlns:a="http://schemas.openxmlformats.org/drawingml/2006/main">
               <a:ext uri="{FF2B5EF4-FFF2-40B4-BE49-F238E27FC236}">
-                <a16:creationId xmlns:a16="http://schemas.microsoft.com/office/drawing/2014/main" id="{80B57FDC-7D9B-4B98-BA65-29D5C8753640}"/>
+                <a16:creationId xmlns:a16="http://schemas.microsoft.com/office/drawing/2014/main" id="{94A2FDF6-AD6E-4E73-BAF6-057DAC20EA5E}"/>
               </a:ext>
             </a:extLst>
           </p:cNvPr>
@@ -4431,7 +4317,7 @@
           <p:cNvPr id="3" name="">
             <a:extLst xmlns:a="http://schemas.openxmlformats.org/drawingml/2006/main">
               <a:ext uri="{FF2B5EF4-FFF2-40B4-BE49-F238E27FC236}">
-                <a16:creationId xmlns:a16="http://schemas.microsoft.com/office/drawing/2014/main" id="{B7B27AA7-C1D1-4E80-89B1-578F03F324F8}"/>
+                <a16:creationId xmlns:a16="http://schemas.microsoft.com/office/drawing/2014/main" id="{57AD309F-6E24-42ED-A561-1B011F3AA7F2}"/>
               </a:ext>
             </a:extLst>
           </p:cNvPr>
@@ -4503,7 +4389,7 @@
           <p:cNvPr id="4" name="">
             <a:extLst xmlns:a="http://schemas.openxmlformats.org/drawingml/2006/main">
               <a:ext uri="{FF2B5EF4-FFF2-40B4-BE49-F238E27FC236}">
-                <a16:creationId xmlns:a16="http://schemas.microsoft.com/office/drawing/2014/main" id="{1FA8564E-57BC-4D6F-A442-B5C955FDB384}"/>
+                <a16:creationId xmlns:a16="http://schemas.microsoft.com/office/drawing/2014/main" id="{9E99AC2C-C04C-4A33-9DFF-3280B6A054B4}"/>
               </a:ext>
             </a:extLst>
           </p:cNvPr>
@@ -4564,7 +4450,7 @@
           <p:cNvPr id="5" name="">
             <a:extLst xmlns:a="http://schemas.openxmlformats.org/drawingml/2006/main">
               <a:ext uri="{FF2B5EF4-FFF2-40B4-BE49-F238E27FC236}">
-                <a16:creationId xmlns:a16="http://schemas.microsoft.com/office/drawing/2014/main" id="{29746AFB-9B4A-4756-8DBB-F8859FC64C49}"/>
+                <a16:creationId xmlns:a16="http://schemas.microsoft.com/office/drawing/2014/main" id="{7D9926AE-14AD-4759-8971-4A286B7CE779}"/>
               </a:ext>
             </a:extLst>
           </p:cNvPr>
@@ -4594,7 +4480,7 @@
           <p:cNvPr id="6" name="">
             <a:extLst xmlns:a="http://schemas.openxmlformats.org/drawingml/2006/main">
               <a:ext uri="{FF2B5EF4-FFF2-40B4-BE49-F238E27FC236}">
-                <a16:creationId xmlns:a16="http://schemas.microsoft.com/office/drawing/2014/main" id="{9BC7694F-885C-4DE4-BABF-389D46719EC1}"/>
+                <a16:creationId xmlns:a16="http://schemas.microsoft.com/office/drawing/2014/main" id="{68273BEC-D80B-4160-B74A-ECF3509F4A71}"/>
               </a:ext>
             </a:extLst>
           </p:cNvPr>
@@ -4626,7 +4512,7 @@
           <p:cNvPr id="7" name="">
             <a:extLst xmlns:a="http://schemas.openxmlformats.org/drawingml/2006/main">
               <a:ext uri="{FF2B5EF4-FFF2-40B4-BE49-F238E27FC236}">
-                <a16:creationId xmlns:a16="http://schemas.microsoft.com/office/drawing/2014/main" id="{3B194A0C-0577-40F6-8CF2-F683D8CB17D4}"/>
+                <a16:creationId xmlns:a16="http://schemas.microsoft.com/office/drawing/2014/main" id="{4134CB9B-7008-471B-B3AB-C2CA1748BF33}"/>
               </a:ext>
             </a:extLst>
           </p:cNvPr>
@@ -4658,7 +4544,7 @@
           <p:cNvPr id="8" name="">
             <a:extLst xmlns:a="http://schemas.openxmlformats.org/drawingml/2006/main">
               <a:ext uri="{FF2B5EF4-FFF2-40B4-BE49-F238E27FC236}">
-                <a16:creationId xmlns:a16="http://schemas.microsoft.com/office/drawing/2014/main" id="{5677A61B-2F44-46F9-8B55-952CA6B23898}"/>
+                <a16:creationId xmlns:a16="http://schemas.microsoft.com/office/drawing/2014/main" id="{CCA58981-C9C8-49CC-9039-B4D497DD114E}"/>
               </a:ext>
             </a:extLst>
           </p:cNvPr>
@@ -4719,7 +4605,7 @@
           <p:cNvPr id="9" name="">
             <a:extLst xmlns:a="http://schemas.openxmlformats.org/drawingml/2006/main">
               <a:ext uri="{FF2B5EF4-FFF2-40B4-BE49-F238E27FC236}">
-                <a16:creationId xmlns:a16="http://schemas.microsoft.com/office/drawing/2014/main" id="{95BA2E71-D1C2-4361-9FF1-277D39C8935F}"/>
+                <a16:creationId xmlns:a16="http://schemas.microsoft.com/office/drawing/2014/main" id="{3160805A-DCA1-4CBE-BBCE-3F0E0DFB7B56}"/>
               </a:ext>
             </a:extLst>
           </p:cNvPr>
@@ -4780,7 +4666,7 @@
           <p:cNvPr id="10" name="">
             <a:extLst xmlns:a="http://schemas.openxmlformats.org/drawingml/2006/main">
               <a:ext uri="{FF2B5EF4-FFF2-40B4-BE49-F238E27FC236}">
-                <a16:creationId xmlns:a16="http://schemas.microsoft.com/office/drawing/2014/main" id="{4E1ED243-C1EE-4A5B-94F7-6EFA776449B4}"/>
+                <a16:creationId xmlns:a16="http://schemas.microsoft.com/office/drawing/2014/main" id="{B17FA9FF-8AA0-4C91-8125-45950D90340F}"/>
               </a:ext>
             </a:extLst>
           </p:cNvPr>
@@ -4841,7 +4727,7 @@
           <p:cNvPr id="11" name="">
             <a:extLst xmlns:a="http://schemas.openxmlformats.org/drawingml/2006/main">
               <a:ext uri="{FF2B5EF4-FFF2-40B4-BE49-F238E27FC236}">
-                <a16:creationId xmlns:a16="http://schemas.microsoft.com/office/drawing/2014/main" id="{621E6C9A-3140-4BD9-9FB1-E40E4B80315F}"/>
+                <a16:creationId xmlns:a16="http://schemas.microsoft.com/office/drawing/2014/main" id="{0A6BEC16-869F-478D-9456-E7F8C16548DD}"/>
               </a:ext>
             </a:extLst>
           </p:cNvPr>
@@ -4902,7 +4788,7 @@
           <p:cNvPr id="12" name="">
             <a:extLst xmlns:a="http://schemas.openxmlformats.org/drawingml/2006/main">
               <a:ext uri="{FF2B5EF4-FFF2-40B4-BE49-F238E27FC236}">
-                <a16:creationId xmlns:a16="http://schemas.microsoft.com/office/drawing/2014/main" id="{6D656236-EAE0-4E62-989E-7F80FE425ABE}"/>
+                <a16:creationId xmlns:a16="http://schemas.microsoft.com/office/drawing/2014/main" id="{3B303C29-1E5D-4932-BCA2-72027F709A47}"/>
               </a:ext>
             </a:extLst>
           </p:cNvPr>
@@ -4963,7 +4849,7 @@
           <p:cNvPr id="13" name="">
             <a:extLst xmlns:a="http://schemas.openxmlformats.org/drawingml/2006/main">
               <a:ext uri="{FF2B5EF4-FFF2-40B4-BE49-F238E27FC236}">
-                <a16:creationId xmlns:a16="http://schemas.microsoft.com/office/drawing/2014/main" id="{11309A61-09A8-47DC-8744-BE229E0610EB}"/>
+                <a16:creationId xmlns:a16="http://schemas.microsoft.com/office/drawing/2014/main" id="{2C4E3ADA-02EE-413A-A4B9-D40C8397D5A7}"/>
               </a:ext>
             </a:extLst>
           </p:cNvPr>
@@ -5024,7 +4910,7 @@
           <p:cNvPr id="14" name="">
             <a:extLst xmlns:a="http://schemas.openxmlformats.org/drawingml/2006/main">
               <a:ext uri="{FF2B5EF4-FFF2-40B4-BE49-F238E27FC236}">
-                <a16:creationId xmlns:a16="http://schemas.microsoft.com/office/drawing/2014/main" id="{79AA46F3-6B96-4E97-861A-2223DE32BF04}"/>
+                <a16:creationId xmlns:a16="http://schemas.microsoft.com/office/drawing/2014/main" id="{93AE8A90-E03B-4622-BC1E-C10ADBCA12F8}"/>
               </a:ext>
             </a:extLst>
           </p:cNvPr>
@@ -5085,7 +4971,7 @@
           <p:cNvPr id="15" name="">
             <a:extLst xmlns:a="http://schemas.openxmlformats.org/drawingml/2006/main">
               <a:ext uri="{FF2B5EF4-FFF2-40B4-BE49-F238E27FC236}">
-                <a16:creationId xmlns:a16="http://schemas.microsoft.com/office/drawing/2014/main" id="{153FD272-25B9-445B-A530-4F726C917AC3}"/>
+                <a16:creationId xmlns:a16="http://schemas.microsoft.com/office/drawing/2014/main" id="{03D495A6-5E78-4894-8BD0-421482F4928F}"/>
               </a:ext>
             </a:extLst>
           </p:cNvPr>
@@ -5144,7 +5030,7 @@
     </p:spTree>
     <p:extLst>
       <p:ext uri="{BB962C8B-B14F-4D97-AF65-F5344CB8AC3E}">
-        <p14:creationId xmlns:p14="http://schemas.microsoft.com/office/powerpoint/2010/main" val="744963093"/>
+        <p14:creationId xmlns:p14="http://schemas.microsoft.com/office/powerpoint/2010/main" val="1537716674"/>
       </p:ext>
     </p:extLst>
   </p:cSld>
@@ -5175,7 +5061,7 @@
           <p:cNvPr id="14" name="">
             <a:extLst xmlns:a="http://schemas.openxmlformats.org/drawingml/2006/main">
               <a:ext uri="{FF2B5EF4-FFF2-40B4-BE49-F238E27FC236}">
-                <a16:creationId xmlns:a16="http://schemas.microsoft.com/office/drawing/2014/main" id="{5FD7B518-E1FD-4816-AB10-2E0BB37B8C82}"/>
+                <a16:creationId xmlns:a16="http://schemas.microsoft.com/office/drawing/2014/main" id="{443E887D-BA2E-4D11-A472-D72FF3A2EADC}"/>
               </a:ext>
             </a:extLst>
           </p:cNvPr>
@@ -5205,7 +5091,7 @@
           <p:cNvPr id="2" name="">
             <a:extLst xmlns:a="http://schemas.openxmlformats.org/drawingml/2006/main">
               <a:ext uri="{FF2B5EF4-FFF2-40B4-BE49-F238E27FC236}">
-                <a16:creationId xmlns:a16="http://schemas.microsoft.com/office/drawing/2014/main" id="{77063008-AECE-44D0-B653-697FD130537B}"/>
+                <a16:creationId xmlns:a16="http://schemas.microsoft.com/office/drawing/2014/main" id="{17AE044A-8268-4B13-A60B-5E8A81ECF8EB}"/>
               </a:ext>
             </a:extLst>
           </p:cNvPr>
@@ -5266,7 +5152,7 @@
           <p:cNvPr id="3" name="">
             <a:extLst xmlns:a="http://schemas.openxmlformats.org/drawingml/2006/main">
               <a:ext uri="{FF2B5EF4-FFF2-40B4-BE49-F238E27FC236}">
-                <a16:creationId xmlns:a16="http://schemas.microsoft.com/office/drawing/2014/main" id="{AE662669-5E68-42BE-96F4-3CABEF4FB97C}"/>
+                <a16:creationId xmlns:a16="http://schemas.microsoft.com/office/drawing/2014/main" id="{8961EE27-45EA-46A7-8A13-8FEA69C07B22}"/>
               </a:ext>
             </a:extLst>
           </p:cNvPr>
@@ -5365,7 +5251,7 @@
           <p:cNvPr id="4" name="">
             <a:extLst xmlns:a="http://schemas.openxmlformats.org/drawingml/2006/main">
               <a:ext uri="{FF2B5EF4-FFF2-40B4-BE49-F238E27FC236}">
-                <a16:creationId xmlns:a16="http://schemas.microsoft.com/office/drawing/2014/main" id="{E5EC0EC2-7077-4245-BABC-EAF11EE50FEA}"/>
+                <a16:creationId xmlns:a16="http://schemas.microsoft.com/office/drawing/2014/main" id="{7AAC9052-51E6-424C-8537-47074EB28778}"/>
               </a:ext>
             </a:extLst>
           </p:cNvPr>
@@ -5426,7 +5312,7 @@
           <p:cNvPr id="5" name="">
             <a:extLst xmlns:a="http://schemas.openxmlformats.org/drawingml/2006/main">
               <a:ext uri="{FF2B5EF4-FFF2-40B4-BE49-F238E27FC236}">
-                <a16:creationId xmlns:a16="http://schemas.microsoft.com/office/drawing/2014/main" id="{0D10D86C-C2FC-4F81-B60E-A759CAE0B7E9}"/>
+                <a16:creationId xmlns:a16="http://schemas.microsoft.com/office/drawing/2014/main" id="{DAFF3F58-613C-40B9-A0C2-94470D795D3D}"/>
               </a:ext>
             </a:extLst>
           </p:cNvPr>
@@ -5487,7 +5373,7 @@
           <p:cNvPr id="6" name="">
             <a:extLst xmlns:a="http://schemas.openxmlformats.org/drawingml/2006/main">
               <a:ext uri="{FF2B5EF4-FFF2-40B4-BE49-F238E27FC236}">
-                <a16:creationId xmlns:a16="http://schemas.microsoft.com/office/drawing/2014/main" id="{4945BCE8-8D04-47AA-B877-58D2B21182F7}"/>
+                <a16:creationId xmlns:a16="http://schemas.microsoft.com/office/drawing/2014/main" id="{F427110D-9992-46FB-A37E-B3E6CA0FA8F4}"/>
               </a:ext>
             </a:extLst>
           </p:cNvPr>
@@ -5521,7 +5407,7 @@
           <p:cNvPr id="7" name="">
             <a:extLst xmlns:a="http://schemas.openxmlformats.org/drawingml/2006/main">
               <a:ext uri="{FF2B5EF4-FFF2-40B4-BE49-F238E27FC236}">
-                <a16:creationId xmlns:a16="http://schemas.microsoft.com/office/drawing/2014/main" id="{C38F647F-92E7-4D45-9019-9719315A4896}"/>
+                <a16:creationId xmlns:a16="http://schemas.microsoft.com/office/drawing/2014/main" id="{964EE853-A003-4F21-A1B9-A204F3D3C0C4}"/>
               </a:ext>
             </a:extLst>
           </p:cNvPr>
@@ -5582,7 +5468,7 @@
           <p:cNvPr id="8" name="">
             <a:extLst xmlns:a="http://schemas.openxmlformats.org/drawingml/2006/main">
               <a:ext uri="{FF2B5EF4-FFF2-40B4-BE49-F238E27FC236}">
-                <a16:creationId xmlns:a16="http://schemas.microsoft.com/office/drawing/2014/main" id="{D61FA999-AC68-4164-A232-55156F1D33FD}"/>
+                <a16:creationId xmlns:a16="http://schemas.microsoft.com/office/drawing/2014/main" id="{40E9B5E4-B6F4-44E3-9118-B3EE4F1CED57}"/>
               </a:ext>
             </a:extLst>
           </p:cNvPr>
@@ -5643,7 +5529,7 @@
           <p:cNvPr id="9" name="">
             <a:extLst xmlns:a="http://schemas.openxmlformats.org/drawingml/2006/main">
               <a:ext uri="{FF2B5EF4-FFF2-40B4-BE49-F238E27FC236}">
-                <a16:creationId xmlns:a16="http://schemas.microsoft.com/office/drawing/2014/main" id="{8BD02177-8A52-4B21-ABCA-556A41F1D8B3}"/>
+                <a16:creationId xmlns:a16="http://schemas.microsoft.com/office/drawing/2014/main" id="{248A8C4C-4EEF-4E2B-B497-C48C6537FCDA}"/>
               </a:ext>
             </a:extLst>
           </p:cNvPr>
@@ -5677,7 +5563,7 @@
           <p:cNvPr id="10" name="">
             <a:extLst xmlns:a="http://schemas.openxmlformats.org/drawingml/2006/main">
               <a:ext uri="{FF2B5EF4-FFF2-40B4-BE49-F238E27FC236}">
-                <a16:creationId xmlns:a16="http://schemas.microsoft.com/office/drawing/2014/main" id="{F3718D05-AEE9-4F6D-A560-FE5EF8756955}"/>
+                <a16:creationId xmlns:a16="http://schemas.microsoft.com/office/drawing/2014/main" id="{993DDFA4-014E-4615-99AE-D437CB43E179}"/>
               </a:ext>
             </a:extLst>
           </p:cNvPr>
@@ -5738,7 +5624,7 @@
           <p:cNvPr id="11" name="">
             <a:extLst xmlns:a="http://schemas.openxmlformats.org/drawingml/2006/main">
               <a:ext uri="{FF2B5EF4-FFF2-40B4-BE49-F238E27FC236}">
-                <a16:creationId xmlns:a16="http://schemas.microsoft.com/office/drawing/2014/main" id="{9D283286-E107-4852-94CA-BF70D8B55F36}"/>
+                <a16:creationId xmlns:a16="http://schemas.microsoft.com/office/drawing/2014/main" id="{37D7BEB7-BF7D-4599-A05C-0D8821B36ADC}"/>
               </a:ext>
             </a:extLst>
           </p:cNvPr>
@@ -5799,7 +5685,7 @@
           <p:cNvPr id="12" name="">
             <a:extLst xmlns:a="http://schemas.openxmlformats.org/drawingml/2006/main">
               <a:ext uri="{FF2B5EF4-FFF2-40B4-BE49-F238E27FC236}">
-                <a16:creationId xmlns:a16="http://schemas.microsoft.com/office/drawing/2014/main" id="{FE057A88-E26C-4DBF-A427-64ED18BFD130}"/>
+                <a16:creationId xmlns:a16="http://schemas.microsoft.com/office/drawing/2014/main" id="{D5BCC54C-A7FF-4E5A-A2A2-FAA8A13D67A0}"/>
               </a:ext>
             </a:extLst>
           </p:cNvPr>
@@ -5860,7 +5746,7 @@
           <p:cNvPr id="13" name="">
             <a:extLst xmlns:a="http://schemas.openxmlformats.org/drawingml/2006/main">
               <a:ext uri="{FF2B5EF4-FFF2-40B4-BE49-F238E27FC236}">
-                <a16:creationId xmlns:a16="http://schemas.microsoft.com/office/drawing/2014/main" id="{E58BDA30-0A35-4772-BAFF-652160C9F6C3}"/>
+                <a16:creationId xmlns:a16="http://schemas.microsoft.com/office/drawing/2014/main" id="{A58962B5-55C9-4117-840F-E927AB53F2D8}"/>
               </a:ext>
             </a:extLst>
           </p:cNvPr>
@@ -5919,7 +5805,7 @@
     </p:spTree>
     <p:extLst>
       <p:ext uri="{BB962C8B-B14F-4D97-AF65-F5344CB8AC3E}">
-        <p14:creationId xmlns:p14="http://schemas.microsoft.com/office/powerpoint/2010/main" val="685625895"/>
+        <p14:creationId xmlns:p14="http://schemas.microsoft.com/office/powerpoint/2010/main" val="357340964"/>
       </p:ext>
     </p:extLst>
   </p:cSld>
@@ -5950,7 +5836,7 @@
           <p:cNvPr id="23" name="">
             <a:extLst xmlns:a="http://schemas.openxmlformats.org/drawingml/2006/main">
               <a:ext uri="{FF2B5EF4-FFF2-40B4-BE49-F238E27FC236}">
-                <a16:creationId xmlns:a16="http://schemas.microsoft.com/office/drawing/2014/main" id="{2C8D51BA-4E7E-4208-A7B5-161CFE21BF86}"/>
+                <a16:creationId xmlns:a16="http://schemas.microsoft.com/office/drawing/2014/main" id="{C26FA0D9-219E-4F00-88AA-CB3FD3E7F9F5}"/>
               </a:ext>
             </a:extLst>
           </p:cNvPr>
@@ -5980,7 +5866,7 @@
           <p:cNvPr id="2" name="">
             <a:extLst xmlns:a="http://schemas.openxmlformats.org/drawingml/2006/main">
               <a:ext uri="{FF2B5EF4-FFF2-40B4-BE49-F238E27FC236}">
-                <a16:creationId xmlns:a16="http://schemas.microsoft.com/office/drawing/2014/main" id="{0CEFDF03-BE7F-4FF8-AE5F-EAA63A998A83}"/>
+                <a16:creationId xmlns:a16="http://schemas.microsoft.com/office/drawing/2014/main" id="{09B558D2-31FF-4FC2-AAC4-567ED6136586}"/>
               </a:ext>
             </a:extLst>
           </p:cNvPr>
@@ -6041,7 +5927,7 @@
           <p:cNvPr id="3" name="">
             <a:extLst xmlns:a="http://schemas.openxmlformats.org/drawingml/2006/main">
               <a:ext uri="{FF2B5EF4-FFF2-40B4-BE49-F238E27FC236}">
-                <a16:creationId xmlns:a16="http://schemas.microsoft.com/office/drawing/2014/main" id="{06FAD294-AECB-4E0E-9456-80F4D65D43EA}"/>
+                <a16:creationId xmlns:a16="http://schemas.microsoft.com/office/drawing/2014/main" id="{AE7585A9-1B90-468A-A25C-7E0D43B885BA}"/>
               </a:ext>
             </a:extLst>
           </p:cNvPr>
@@ -6113,7 +5999,7 @@
           <p:cNvPr id="4" name="">
             <a:extLst xmlns:a="http://schemas.openxmlformats.org/drawingml/2006/main">
               <a:ext uri="{FF2B5EF4-FFF2-40B4-BE49-F238E27FC236}">
-                <a16:creationId xmlns:a16="http://schemas.microsoft.com/office/drawing/2014/main" id="{B8BB3823-8FA5-4A99-ABC9-A3D3D45BB9AB}"/>
+                <a16:creationId xmlns:a16="http://schemas.microsoft.com/office/drawing/2014/main" id="{913B67BC-559B-4922-B0AE-ED63CC90EB97}"/>
               </a:ext>
             </a:extLst>
           </p:cNvPr>
@@ -6143,7 +6029,7 @@
           <p:cNvPr id="5" name="">
             <a:extLst xmlns:a="http://schemas.openxmlformats.org/drawingml/2006/main">
               <a:ext uri="{FF2B5EF4-FFF2-40B4-BE49-F238E27FC236}">
-                <a16:creationId xmlns:a16="http://schemas.microsoft.com/office/drawing/2014/main" id="{8D9644C1-8F5F-4E72-99FE-B2C35787D487}"/>
+                <a16:creationId xmlns:a16="http://schemas.microsoft.com/office/drawing/2014/main" id="{CD1E7552-95FC-4404-818B-D38D4C753D43}"/>
               </a:ext>
             </a:extLst>
           </p:cNvPr>
@@ -6175,7 +6061,7 @@
           <p:cNvPr id="6" name="">
             <a:extLst xmlns:a="http://schemas.openxmlformats.org/drawingml/2006/main">
               <a:ext uri="{FF2B5EF4-FFF2-40B4-BE49-F238E27FC236}">
-                <a16:creationId xmlns:a16="http://schemas.microsoft.com/office/drawing/2014/main" id="{9BDAA1A3-D047-4F03-A7E3-7904B89EF706}"/>
+                <a16:creationId xmlns:a16="http://schemas.microsoft.com/office/drawing/2014/main" id="{4918B1E4-3C42-484B-B2AF-E377AF589419}"/>
               </a:ext>
             </a:extLst>
           </p:cNvPr>
@@ -6236,7 +6122,7 @@
           <p:cNvPr id="7" name="">
             <a:extLst xmlns:a="http://schemas.openxmlformats.org/drawingml/2006/main">
               <a:ext uri="{FF2B5EF4-FFF2-40B4-BE49-F238E27FC236}">
-                <a16:creationId xmlns:a16="http://schemas.microsoft.com/office/drawing/2014/main" id="{0DF09E38-99D5-423D-96C1-92820FB56D84}"/>
+                <a16:creationId xmlns:a16="http://schemas.microsoft.com/office/drawing/2014/main" id="{4A1B7642-3F04-4367-BDB2-9ACEE5C71977}"/>
               </a:ext>
             </a:extLst>
           </p:cNvPr>
@@ -6297,7 +6183,7 @@
           <p:cNvPr id="8" name="">
             <a:extLst xmlns:a="http://schemas.openxmlformats.org/drawingml/2006/main">
               <a:ext uri="{FF2B5EF4-FFF2-40B4-BE49-F238E27FC236}">
-                <a16:creationId xmlns:a16="http://schemas.microsoft.com/office/drawing/2014/main" id="{C0961D16-2862-409F-8FEA-0762C410FD74}"/>
+                <a16:creationId xmlns:a16="http://schemas.microsoft.com/office/drawing/2014/main" id="{5ADCA9DE-43CB-4F78-9B98-1485C805A885}"/>
               </a:ext>
             </a:extLst>
           </p:cNvPr>
@@ -6358,7 +6244,7 @@
           <p:cNvPr id="9" name="">
             <a:extLst xmlns:a="http://schemas.openxmlformats.org/drawingml/2006/main">
               <a:ext uri="{FF2B5EF4-FFF2-40B4-BE49-F238E27FC236}">
-                <a16:creationId xmlns:a16="http://schemas.microsoft.com/office/drawing/2014/main" id="{AFDA4337-8C8B-4480-B03A-D8B4A26E243B}"/>
+                <a16:creationId xmlns:a16="http://schemas.microsoft.com/office/drawing/2014/main" id="{B7441474-60C1-464A-9AEC-F54FDE91EF26}"/>
               </a:ext>
             </a:extLst>
           </p:cNvPr>
@@ -6390,7 +6276,7 @@
           <p:cNvPr id="10" name="">
             <a:extLst xmlns:a="http://schemas.openxmlformats.org/drawingml/2006/main">
               <a:ext uri="{FF2B5EF4-FFF2-40B4-BE49-F238E27FC236}">
-                <a16:creationId xmlns:a16="http://schemas.microsoft.com/office/drawing/2014/main" id="{7662F0C4-F671-4151-AB86-EF4D8CB3AD80}"/>
+                <a16:creationId xmlns:a16="http://schemas.microsoft.com/office/drawing/2014/main" id="{F262BFB6-4E8F-453C-9588-7447F8B59C43}"/>
               </a:ext>
             </a:extLst>
           </p:cNvPr>
@@ -6451,7 +6337,7 @@
           <p:cNvPr id="11" name="">
             <a:extLst xmlns:a="http://schemas.openxmlformats.org/drawingml/2006/main">
               <a:ext uri="{FF2B5EF4-FFF2-40B4-BE49-F238E27FC236}">
-                <a16:creationId xmlns:a16="http://schemas.microsoft.com/office/drawing/2014/main" id="{A8A0A516-A330-4D24-98C8-4210D69108B6}"/>
+                <a16:creationId xmlns:a16="http://schemas.microsoft.com/office/drawing/2014/main" id="{DF6A58E6-9724-4CC8-B707-2A272DD726DF}"/>
               </a:ext>
             </a:extLst>
           </p:cNvPr>
@@ -6512,7 +6398,7 @@
           <p:cNvPr id="12" name="">
             <a:extLst xmlns:a="http://schemas.openxmlformats.org/drawingml/2006/main">
               <a:ext uri="{FF2B5EF4-FFF2-40B4-BE49-F238E27FC236}">
-                <a16:creationId xmlns:a16="http://schemas.microsoft.com/office/drawing/2014/main" id="{9AB321E1-D971-4765-8566-74A40484F1F7}"/>
+                <a16:creationId xmlns:a16="http://schemas.microsoft.com/office/drawing/2014/main" id="{A680C295-436C-4A4C-8AD0-ECAFDA075131}"/>
               </a:ext>
             </a:extLst>
           </p:cNvPr>
@@ -6573,7 +6459,7 @@
           <p:cNvPr id="13" name="">
             <a:extLst xmlns:a="http://schemas.openxmlformats.org/drawingml/2006/main">
               <a:ext uri="{FF2B5EF4-FFF2-40B4-BE49-F238E27FC236}">
-                <a16:creationId xmlns:a16="http://schemas.microsoft.com/office/drawing/2014/main" id="{94FFE256-17EE-443A-A88C-72568C50E9EF}"/>
+                <a16:creationId xmlns:a16="http://schemas.microsoft.com/office/drawing/2014/main" id="{47AD4527-A54D-4F84-B5EB-631722DDAFF0}"/>
               </a:ext>
             </a:extLst>
           </p:cNvPr>
@@ -6605,7 +6491,7 @@
           <p:cNvPr id="14" name="">
             <a:extLst xmlns:a="http://schemas.openxmlformats.org/drawingml/2006/main">
               <a:ext uri="{FF2B5EF4-FFF2-40B4-BE49-F238E27FC236}">
-                <a16:creationId xmlns:a16="http://schemas.microsoft.com/office/drawing/2014/main" id="{8E61EA15-1701-4261-B13A-CEE96AC2BE49}"/>
+                <a16:creationId xmlns:a16="http://schemas.microsoft.com/office/drawing/2014/main" id="{99477C1E-7C91-42A8-88A4-2BF0369A7CD4}"/>
               </a:ext>
             </a:extLst>
           </p:cNvPr>
@@ -6666,7 +6552,7 @@
           <p:cNvPr id="15" name="">
             <a:extLst xmlns:a="http://schemas.openxmlformats.org/drawingml/2006/main">
               <a:ext uri="{FF2B5EF4-FFF2-40B4-BE49-F238E27FC236}">
-                <a16:creationId xmlns:a16="http://schemas.microsoft.com/office/drawing/2014/main" id="{CA1CEE05-3E7E-4ECC-AE40-3E64DAFDA46D}"/>
+                <a16:creationId xmlns:a16="http://schemas.microsoft.com/office/drawing/2014/main" id="{F1DE4538-0A41-40C8-9014-DDE6DC5686CA}"/>
               </a:ext>
             </a:extLst>
           </p:cNvPr>
@@ -6727,7 +6613,7 @@
           <p:cNvPr id="16" name="">
             <a:extLst xmlns:a="http://schemas.openxmlformats.org/drawingml/2006/main">
               <a:ext uri="{FF2B5EF4-FFF2-40B4-BE49-F238E27FC236}">
-                <a16:creationId xmlns:a16="http://schemas.microsoft.com/office/drawing/2014/main" id="{1EDE29D9-F4E2-4E3F-934E-CC59665B119A}"/>
+                <a16:creationId xmlns:a16="http://schemas.microsoft.com/office/drawing/2014/main" id="{C8F6F28E-BE0C-425D-A643-7867841F1431}"/>
               </a:ext>
             </a:extLst>
           </p:cNvPr>
@@ -6788,7 +6674,7 @@
           <p:cNvPr id="17" name="">
             <a:extLst xmlns:a="http://schemas.openxmlformats.org/drawingml/2006/main">
               <a:ext uri="{FF2B5EF4-FFF2-40B4-BE49-F238E27FC236}">
-                <a16:creationId xmlns:a16="http://schemas.microsoft.com/office/drawing/2014/main" id="{7D56B4CA-E2E5-4446-8EAC-5000AB250586}"/>
+                <a16:creationId xmlns:a16="http://schemas.microsoft.com/office/drawing/2014/main" id="{BF19B58A-66B8-4E2B-8983-B3BCB1A8A590}"/>
               </a:ext>
             </a:extLst>
           </p:cNvPr>
@@ -6820,7 +6706,7 @@
           <p:cNvPr id="18" name="">
             <a:extLst xmlns:a="http://schemas.openxmlformats.org/drawingml/2006/main">
               <a:ext uri="{FF2B5EF4-FFF2-40B4-BE49-F238E27FC236}">
-                <a16:creationId xmlns:a16="http://schemas.microsoft.com/office/drawing/2014/main" id="{E9586B17-978E-43B2-B42C-7F39C4050E81}"/>
+                <a16:creationId xmlns:a16="http://schemas.microsoft.com/office/drawing/2014/main" id="{A54978FB-B6D3-4B74-A4EC-7CED396FBA49}"/>
               </a:ext>
             </a:extLst>
           </p:cNvPr>
@@ -6881,7 +6767,7 @@
           <p:cNvPr id="19" name="">
             <a:extLst xmlns:a="http://schemas.openxmlformats.org/drawingml/2006/main">
               <a:ext uri="{FF2B5EF4-FFF2-40B4-BE49-F238E27FC236}">
-                <a16:creationId xmlns:a16="http://schemas.microsoft.com/office/drawing/2014/main" id="{2BAF3865-E077-4E17-8B97-DCA525373037}"/>
+                <a16:creationId xmlns:a16="http://schemas.microsoft.com/office/drawing/2014/main" id="{AB0BF79D-F712-4295-95F8-6B2543349E48}"/>
               </a:ext>
             </a:extLst>
           </p:cNvPr>
@@ -6942,7 +6828,7 @@
           <p:cNvPr id="20" name="">
             <a:extLst xmlns:a="http://schemas.openxmlformats.org/drawingml/2006/main">
               <a:ext uri="{FF2B5EF4-FFF2-40B4-BE49-F238E27FC236}">
-                <a16:creationId xmlns:a16="http://schemas.microsoft.com/office/drawing/2014/main" id="{5942E059-6A28-48A2-B7BF-58A08671F426}"/>
+                <a16:creationId xmlns:a16="http://schemas.microsoft.com/office/drawing/2014/main" id="{75647260-665C-4C14-AB06-C437665AF3B5}"/>
               </a:ext>
             </a:extLst>
           </p:cNvPr>
@@ -7003,7 +6889,7 @@
           <p:cNvPr id="21" name="">
             <a:extLst xmlns:a="http://schemas.openxmlformats.org/drawingml/2006/main">
               <a:ext uri="{FF2B5EF4-FFF2-40B4-BE49-F238E27FC236}">
-                <a16:creationId xmlns:a16="http://schemas.microsoft.com/office/drawing/2014/main" id="{D865DBC1-66CD-47E3-9AB2-1F0C5F3E6322}"/>
+                <a16:creationId xmlns:a16="http://schemas.microsoft.com/office/drawing/2014/main" id="{5DE9C319-1EB3-4119-9174-50E724664983}"/>
               </a:ext>
             </a:extLst>
           </p:cNvPr>
@@ -7064,7 +6950,7 @@
           <p:cNvPr id="22" name="">
             <a:extLst xmlns:a="http://schemas.openxmlformats.org/drawingml/2006/main">
               <a:ext uri="{FF2B5EF4-FFF2-40B4-BE49-F238E27FC236}">
-                <a16:creationId xmlns:a16="http://schemas.microsoft.com/office/drawing/2014/main" id="{94DFDC80-EA46-4387-A54C-D9800141B8CE}"/>
+                <a16:creationId xmlns:a16="http://schemas.microsoft.com/office/drawing/2014/main" id="{63D640B1-D882-45E5-B774-6DA1C9DA993F}"/>
               </a:ext>
             </a:extLst>
           </p:cNvPr>
@@ -7123,7 +7009,7 @@
     </p:spTree>
     <p:extLst>
       <p:ext uri="{BB962C8B-B14F-4D97-AF65-F5344CB8AC3E}">
-        <p14:creationId xmlns:p14="http://schemas.microsoft.com/office/powerpoint/2010/main" val="913813093"/>
+        <p14:creationId xmlns:p14="http://schemas.microsoft.com/office/powerpoint/2010/main" val="962412014"/>
       </p:ext>
     </p:extLst>
   </p:cSld>
@@ -7154,7 +7040,7 @@
           <p:cNvPr id="8" name="">
             <a:extLst xmlns:a="http://schemas.openxmlformats.org/drawingml/2006/main">
               <a:ext uri="{FF2B5EF4-FFF2-40B4-BE49-F238E27FC236}">
-                <a16:creationId xmlns:a16="http://schemas.microsoft.com/office/drawing/2014/main" id="{86D3FEC2-0171-4968-A019-759DA86CDEA1}"/>
+                <a16:creationId xmlns:a16="http://schemas.microsoft.com/office/drawing/2014/main" id="{E30B41E0-98CF-4D96-BBA6-FB6E0AF5A782}"/>
               </a:ext>
             </a:extLst>
           </p:cNvPr>
@@ -7184,7 +7070,7 @@
           <p:cNvPr id="2" name="">
             <a:extLst xmlns:a="http://schemas.openxmlformats.org/drawingml/2006/main">
               <a:ext uri="{FF2B5EF4-FFF2-40B4-BE49-F238E27FC236}">
-                <a16:creationId xmlns:a16="http://schemas.microsoft.com/office/drawing/2014/main" id="{808A51E2-A7FA-4977-953A-9C0E4A57B3D7}"/>
+                <a16:creationId xmlns:a16="http://schemas.microsoft.com/office/drawing/2014/main" id="{E4F5FFFF-9848-4557-9721-413489B5E342}"/>
               </a:ext>
             </a:extLst>
           </p:cNvPr>
@@ -7245,7 +7131,7 @@
           <p:cNvPr id="3" name="">
             <a:extLst xmlns:a="http://schemas.openxmlformats.org/drawingml/2006/main">
               <a:ext uri="{FF2B5EF4-FFF2-40B4-BE49-F238E27FC236}">
-                <a16:creationId xmlns:a16="http://schemas.microsoft.com/office/drawing/2014/main" id="{D27F1C06-52E7-431E-8F37-78321AA4F9D8}"/>
+                <a16:creationId xmlns:a16="http://schemas.microsoft.com/office/drawing/2014/main" id="{E0EFE717-65F1-48FF-A87A-F30A606D4837}"/>
               </a:ext>
             </a:extLst>
           </p:cNvPr>
@@ -7344,7 +7230,7 @@
           <p:cNvPr id="4" name="">
             <a:extLst xmlns:a="http://schemas.openxmlformats.org/drawingml/2006/main">
               <a:ext uri="{FF2B5EF4-FFF2-40B4-BE49-F238E27FC236}">
-                <a16:creationId xmlns:a16="http://schemas.microsoft.com/office/drawing/2014/main" id="{C6C347F9-540E-4E32-9780-442C6EE7ADF8}"/>
+                <a16:creationId xmlns:a16="http://schemas.microsoft.com/office/drawing/2014/main" id="{FF86E5F4-C364-4583-AEE4-5DC7F4A1F05D}"/>
               </a:ext>
             </a:extLst>
           </p:cNvPr>
@@ -7409,7 +7295,7 @@
           <p:nvPr/>
         </p:nvPicPr>
         <p:blipFill>
-          <a:blip xmlns:r="http://schemas.openxmlformats.org/officeDocument/2006/relationships" xmlns:a="http://schemas.openxmlformats.org/drawingml/2006/main" r:embed="R81d5d5a0b1a04f9c"/>
+          <a:blip xmlns:r="http://schemas.openxmlformats.org/officeDocument/2006/relationships" xmlns:a="http://schemas.openxmlformats.org/drawingml/2006/main" r:embed="R97c139014b1f4b0f"/>
           <a:srcRect xmlns:a="http://schemas.openxmlformats.org/drawingml/2006/main" l="0" t="751" r="0" b="751"/>
           <a:stretch xmlns:a="http://schemas.openxmlformats.org/drawingml/2006/main">
             <a:fillRect l="0" t="0" r="0" b="0"/>
@@ -7432,7 +7318,7 @@
           <p:cNvPr id="6" name="">
             <a:extLst xmlns:a="http://schemas.openxmlformats.org/drawingml/2006/main">
               <a:ext uri="{FF2B5EF4-FFF2-40B4-BE49-F238E27FC236}">
-                <a16:creationId xmlns:a16="http://schemas.microsoft.com/office/drawing/2014/main" id="{F5CD8004-4D53-47FA-A0FF-2B9531B760BF}"/>
+                <a16:creationId xmlns:a16="http://schemas.microsoft.com/office/drawing/2014/main" id="{0C4F1F24-3CBA-4ED2-BA68-E6A2CB28BA64}"/>
               </a:ext>
             </a:extLst>
           </p:cNvPr>
@@ -7493,7 +7379,7 @@
           <p:cNvPr id="7" name="">
             <a:extLst xmlns:a="http://schemas.openxmlformats.org/drawingml/2006/main">
               <a:ext uri="{FF2B5EF4-FFF2-40B4-BE49-F238E27FC236}">
-                <a16:creationId xmlns:a16="http://schemas.microsoft.com/office/drawing/2014/main" id="{E7828DD7-102C-4672-937A-4EE53740788B}"/>
+                <a16:creationId xmlns:a16="http://schemas.microsoft.com/office/drawing/2014/main" id="{0F39DC59-780F-418F-A7ED-BB20BF71EBC7}"/>
               </a:ext>
             </a:extLst>
           </p:cNvPr>
@@ -7552,7 +7438,7 @@
     </p:spTree>
     <p:extLst>
       <p:ext uri="{BB962C8B-B14F-4D97-AF65-F5344CB8AC3E}">
-        <p14:creationId xmlns:p14="http://schemas.microsoft.com/office/powerpoint/2010/main" val="475122437"/>
+        <p14:creationId xmlns:p14="http://schemas.microsoft.com/office/powerpoint/2010/main" val="1066960934"/>
       </p:ext>
     </p:extLst>
   </p:cSld>
@@ -7583,7 +7469,7 @@
           <p:cNvPr id="16" name="">
             <a:extLst xmlns:a="http://schemas.openxmlformats.org/drawingml/2006/main">
               <a:ext uri="{FF2B5EF4-FFF2-40B4-BE49-F238E27FC236}">
-                <a16:creationId xmlns:a16="http://schemas.microsoft.com/office/drawing/2014/main" id="{CE4F6BFC-BA63-49EF-B127-B13A72B46D05}"/>
+                <a16:creationId xmlns:a16="http://schemas.microsoft.com/office/drawing/2014/main" id="{5245B77D-1425-4BF8-AE8C-44D33C1FD0F4}"/>
               </a:ext>
             </a:extLst>
           </p:cNvPr>
@@ -7613,7 +7499,7 @@
           <p:cNvPr id="2" name="">
             <a:extLst xmlns:a="http://schemas.openxmlformats.org/drawingml/2006/main">
               <a:ext uri="{FF2B5EF4-FFF2-40B4-BE49-F238E27FC236}">
-                <a16:creationId xmlns:a16="http://schemas.microsoft.com/office/drawing/2014/main" id="{D7DDEE10-971E-4759-832D-A2EA827CB016}"/>
+                <a16:creationId xmlns:a16="http://schemas.microsoft.com/office/drawing/2014/main" id="{25A01FD8-EB48-4518-A710-92776649E072}"/>
               </a:ext>
             </a:extLst>
           </p:cNvPr>
@@ -7674,7 +7560,7 @@
           <p:cNvPr id="3" name="">
             <a:extLst xmlns:a="http://schemas.openxmlformats.org/drawingml/2006/main">
               <a:ext uri="{FF2B5EF4-FFF2-40B4-BE49-F238E27FC236}">
-                <a16:creationId xmlns:a16="http://schemas.microsoft.com/office/drawing/2014/main" id="{48D8DA12-E97C-49F8-96CF-110BA148C16E}"/>
+                <a16:creationId xmlns:a16="http://schemas.microsoft.com/office/drawing/2014/main" id="{A8CB34F0-F086-4F40-9EE0-271A616A7C90}"/>
               </a:ext>
             </a:extLst>
           </p:cNvPr>
@@ -7773,7 +7659,7 @@
           <p:cNvPr id="4" name="">
             <a:extLst xmlns:a="http://schemas.openxmlformats.org/drawingml/2006/main">
               <a:ext uri="{FF2B5EF4-FFF2-40B4-BE49-F238E27FC236}">
-                <a16:creationId xmlns:a16="http://schemas.microsoft.com/office/drawing/2014/main" id="{E04F3DE9-763D-4378-A824-663B6597BFAD}"/>
+                <a16:creationId xmlns:a16="http://schemas.microsoft.com/office/drawing/2014/main" id="{F32730E3-AEB4-4255-8215-38D809D52B92}"/>
               </a:ext>
             </a:extLst>
           </p:cNvPr>
@@ -7803,7 +7689,7 @@
           <p:cNvPr id="5" name="">
             <a:extLst xmlns:a="http://schemas.openxmlformats.org/drawingml/2006/main">
               <a:ext uri="{FF2B5EF4-FFF2-40B4-BE49-F238E27FC236}">
-                <a16:creationId xmlns:a16="http://schemas.microsoft.com/office/drawing/2014/main" id="{C04994BF-B110-4509-AF8C-90DFFB5A9FE6}"/>
+                <a16:creationId xmlns:a16="http://schemas.microsoft.com/office/drawing/2014/main" id="{F5FF5074-421C-4874-B247-0BAA91DDA219}"/>
               </a:ext>
             </a:extLst>
           </p:cNvPr>
@@ -7864,7 +7750,7 @@
           <p:cNvPr id="6" name="">
             <a:extLst xmlns:a="http://schemas.openxmlformats.org/drawingml/2006/main">
               <a:ext uri="{FF2B5EF4-FFF2-40B4-BE49-F238E27FC236}">
-                <a16:creationId xmlns:a16="http://schemas.microsoft.com/office/drawing/2014/main" id="{03F3EAF1-E969-4D0A-8A24-44F950094A35}"/>
+                <a16:creationId xmlns:a16="http://schemas.microsoft.com/office/drawing/2014/main" id="{FA6F6D2D-22E6-45DF-9B56-B283C6EE851F}"/>
               </a:ext>
             </a:extLst>
           </p:cNvPr>
@@ -7925,7 +7811,7 @@
           <p:cNvPr id="7" name="">
             <a:extLst xmlns:a="http://schemas.openxmlformats.org/drawingml/2006/main">
               <a:ext uri="{FF2B5EF4-FFF2-40B4-BE49-F238E27FC236}">
-                <a16:creationId xmlns:a16="http://schemas.microsoft.com/office/drawing/2014/main" id="{09A6B164-3030-48A7-B354-14EEF1330395}"/>
+                <a16:creationId xmlns:a16="http://schemas.microsoft.com/office/drawing/2014/main" id="{4A2892EF-216C-45C7-AAE7-3EBE7FEF5C4B}"/>
               </a:ext>
             </a:extLst>
           </p:cNvPr>
@@ -7986,7 +7872,7 @@
           <p:cNvPr id="8" name="">
             <a:extLst xmlns:a="http://schemas.openxmlformats.org/drawingml/2006/main">
               <a:ext uri="{FF2B5EF4-FFF2-40B4-BE49-F238E27FC236}">
-                <a16:creationId xmlns:a16="http://schemas.microsoft.com/office/drawing/2014/main" id="{7488DA67-0360-4BDE-936A-BEBE49B6E7F2}"/>
+                <a16:creationId xmlns:a16="http://schemas.microsoft.com/office/drawing/2014/main" id="{F2E440B1-AA72-4A6A-ADAC-12D02A86955B}"/>
               </a:ext>
             </a:extLst>
           </p:cNvPr>
@@ -8047,7 +7933,7 @@
           <p:cNvPr id="9" name="">
             <a:extLst xmlns:a="http://schemas.openxmlformats.org/drawingml/2006/main">
               <a:ext uri="{FF2B5EF4-FFF2-40B4-BE49-F238E27FC236}">
-                <a16:creationId xmlns:a16="http://schemas.microsoft.com/office/drawing/2014/main" id="{1149AC64-36EE-43CF-8158-7E7B1810F563}"/>
+                <a16:creationId xmlns:a16="http://schemas.microsoft.com/office/drawing/2014/main" id="{DA594E1E-1F66-4F36-971A-30027296C9E5}"/>
               </a:ext>
             </a:extLst>
           </p:cNvPr>
@@ -8108,7 +7994,7 @@
           <p:cNvPr id="10" name="">
             <a:extLst xmlns:a="http://schemas.openxmlformats.org/drawingml/2006/main">
               <a:ext uri="{FF2B5EF4-FFF2-40B4-BE49-F238E27FC236}">
-                <a16:creationId xmlns:a16="http://schemas.microsoft.com/office/drawing/2014/main" id="{001767BC-DE44-4419-A294-6BA165B69924}"/>
+                <a16:creationId xmlns:a16="http://schemas.microsoft.com/office/drawing/2014/main" id="{9D56FCA9-9774-43FE-BB5D-C63FA53E8D85}"/>
               </a:ext>
             </a:extLst>
           </p:cNvPr>
@@ -8169,7 +8055,7 @@
           <p:cNvPr id="11" name="">
             <a:extLst xmlns:a="http://schemas.openxmlformats.org/drawingml/2006/main">
               <a:ext uri="{FF2B5EF4-FFF2-40B4-BE49-F238E27FC236}">
-                <a16:creationId xmlns:a16="http://schemas.microsoft.com/office/drawing/2014/main" id="{A22B282B-D872-4F81-820B-5BAECECB495B}"/>
+                <a16:creationId xmlns:a16="http://schemas.microsoft.com/office/drawing/2014/main" id="{CB8B6BF5-F217-4AA6-AEF0-EFCD62A9D245}"/>
               </a:ext>
             </a:extLst>
           </p:cNvPr>
@@ -8230,7 +8116,7 @@
           <p:cNvPr id="12" name="">
             <a:extLst xmlns:a="http://schemas.openxmlformats.org/drawingml/2006/main">
               <a:ext uri="{FF2B5EF4-FFF2-40B4-BE49-F238E27FC236}">
-                <a16:creationId xmlns:a16="http://schemas.microsoft.com/office/drawing/2014/main" id="{A6EA28A8-A811-4A0F-83C3-7DF8BDE36BEF}"/>
+                <a16:creationId xmlns:a16="http://schemas.microsoft.com/office/drawing/2014/main" id="{B265DDD4-7AB4-41A8-A1E4-24AE0ED70B3C}"/>
               </a:ext>
             </a:extLst>
           </p:cNvPr>
@@ -8291,7 +8177,7 @@
           <p:cNvPr id="13" name="">
             <a:extLst xmlns:a="http://schemas.openxmlformats.org/drawingml/2006/main">
               <a:ext uri="{FF2B5EF4-FFF2-40B4-BE49-F238E27FC236}">
-                <a16:creationId xmlns:a16="http://schemas.microsoft.com/office/drawing/2014/main" id="{EB2AAE5F-D3BE-418C-B905-F37147763025}"/>
+                <a16:creationId xmlns:a16="http://schemas.microsoft.com/office/drawing/2014/main" id="{61E526BB-7315-4374-A056-10D14609E503}"/>
               </a:ext>
             </a:extLst>
           </p:cNvPr>
@@ -8325,7 +8211,7 @@
           <p:cNvPr id="14" name="">
             <a:extLst xmlns:a="http://schemas.openxmlformats.org/drawingml/2006/main">
               <a:ext uri="{FF2B5EF4-FFF2-40B4-BE49-F238E27FC236}">
-                <a16:creationId xmlns:a16="http://schemas.microsoft.com/office/drawing/2014/main" id="{3DB25BF3-2A33-4B6F-A8BF-911FF1F6C623}"/>
+                <a16:creationId xmlns:a16="http://schemas.microsoft.com/office/drawing/2014/main" id="{E49873B4-5465-4681-A130-967469502E4B}"/>
               </a:ext>
             </a:extLst>
           </p:cNvPr>
@@ -8386,7 +8272,7 @@
           <p:cNvPr id="15" name="">
             <a:extLst xmlns:a="http://schemas.openxmlformats.org/drawingml/2006/main">
               <a:ext uri="{FF2B5EF4-FFF2-40B4-BE49-F238E27FC236}">
-                <a16:creationId xmlns:a16="http://schemas.microsoft.com/office/drawing/2014/main" id="{39E97B94-5E47-4575-9938-C38CDF707378}"/>
+                <a16:creationId xmlns:a16="http://schemas.microsoft.com/office/drawing/2014/main" id="{0E5FBFCC-1DE5-4F45-82C9-047C26C77F6F}"/>
               </a:ext>
             </a:extLst>
           </p:cNvPr>
@@ -8445,7 +8331,7 @@
     </p:spTree>
     <p:extLst>
       <p:ext uri="{BB962C8B-B14F-4D97-AF65-F5344CB8AC3E}">
-        <p14:creationId xmlns:p14="http://schemas.microsoft.com/office/powerpoint/2010/main" val="643919384"/>
+        <p14:creationId xmlns:p14="http://schemas.microsoft.com/office/powerpoint/2010/main" val="929687138"/>
       </p:ext>
     </p:extLst>
   </p:cSld>
@@ -8471,119 +8357,85 @@
       <p:grpSpPr>
         <a:xfrm xmlns:a="http://schemas.openxmlformats.org/drawingml/2006/main"/>
       </p:grpSpPr>
-      <p:pic>
-        <p:nvPicPr>
-          <p:cNvPr id="12" name=""/>
-          <p:cNvPicPr>
-            <a:picLocks xmlns:a="http://schemas.openxmlformats.org/drawingml/2006/main" noChangeAspect="1"/>
-          </p:cNvPicPr>
-          <p:nvPr/>
-        </p:nvPicPr>
-        <p:blipFill>
-          <a:blip xmlns:r="http://schemas.openxmlformats.org/officeDocument/2006/relationships" xmlns:a="http://schemas.openxmlformats.org/drawingml/2006/main" r:embed="R9cfab94bc91447f8"/>
-          <a:srcRect xmlns:a="http://schemas.openxmlformats.org/drawingml/2006/main" l="0" t="0" r="0" b="0"/>
-          <a:stretch xmlns:a="http://schemas.openxmlformats.org/drawingml/2006/main">
-            <a:fillRect l="0" t="0" r="0" b="0"/>
-          </a:stretch>
-        </p:blipFill>
-        <p:spPr>
-          <a:xfrm xmlns:a="http://schemas.openxmlformats.org/drawingml/2006/main">
-            <a:off x="0" y="0"/>
-            <a:ext cx="10287000" cy="12858750"/>
-          </a:xfrm>
-          <a:prstGeom xmlns:a="http://schemas.openxmlformats.org/drawingml/2006/main" prst="rect">
-            <a:avLst/>
-          </a:prstGeom>
-        </p:spPr>
-      </p:pic>
+      <p:sp>
+        <p:nvSpPr>
+          <p:cNvPr id="8" name="">
+            <a:extLst xmlns:a="http://schemas.openxmlformats.org/drawingml/2006/main">
+              <a:ext uri="{FF2B5EF4-FFF2-40B4-BE49-F238E27FC236}">
+                <a16:creationId xmlns:a16="http://schemas.microsoft.com/office/drawing/2014/main" id="{58427DD8-86C2-448E-ADA0-A6EDA6AEA0AB}"/>
+              </a:ext>
+            </a:extLst>
+          </p:cNvPr>
+          <p:cNvSpPr>
+            <a:spLocks xmlns:a="http://schemas.openxmlformats.org/drawingml/2006/main" noGrp="1"/>
+          </p:cNvSpPr>
+          <p:nvPr/>
+        </p:nvSpPr>
+        <p:spPr>
+          <a:xfrm xmlns:a="http://schemas.openxmlformats.org/drawingml/2006/main">
+            <a:off x="762000" y="1000125"/>
+            <a:ext cx="8763000" cy="428625"/>
+          </a:xfrm>
+          <a:prstGeom xmlns:a="http://schemas.openxmlformats.org/drawingml/2006/main" prst="rect">
+            <a:avLst/>
+          </a:prstGeom>
+          <a:noFill xmlns:a="http://schemas.openxmlformats.org/drawingml/2006/main"/>
+          <a:ln xmlns:a="http://schemas.openxmlformats.org/drawingml/2006/main" w="0">
+            <a:noFill/>
+          </a:ln>
+        </p:spPr>
+        <p:txBody>
+          <a:bodyPr xmlns:a="http://schemas.openxmlformats.org/drawingml/2006/main" lIns="0" tIns="0" rIns="0" bIns="0" anchor="t">
+            <a:noAutofit/>
+          </a:bodyPr>
+          <a:lstStyle xmlns:a="http://schemas.openxmlformats.org/drawingml/2006/main"/>
+          <a:p xmlns:a="http://schemas.openxmlformats.org/drawingml/2006/main">
+            <a:pPr algn="l">
+              <a:lnSpc>
+                <a:spcPct val="100000"/>
+              </a:lnSpc>
+              <a:buNone/>
+              <a:defRPr sz="1875" b="1">
+                <a:solidFill>
+                  <a:srgbClr val="C8FF00"/>
+                </a:solidFill>
+                <a:latin typeface="Menlo"/>
+                <a:ea typeface="Menlo"/>
+                <a:cs typeface="Menlo"/>
+              </a:defRPr>
+            </a:pPr>
+            <a:r>
+              <a:rPr sz="1875" b="1">
+                <a:solidFill>
+                  <a:srgbClr val="C8FF00"/>
+                </a:solidFill>
+                <a:latin typeface="Menlo"/>
+                <a:ea typeface="Menlo"/>
+                <a:cs typeface="Menlo"/>
+              </a:rPr>
+              <a:t>RESUMEN</a:t>
+            </a:r>
+          </a:p>
+        </p:txBody>
+      </p:sp>
       <p:sp>
         <p:nvSpPr>
           <p:cNvPr id="2" name="">
             <a:extLst xmlns:a="http://schemas.openxmlformats.org/drawingml/2006/main">
               <a:ext uri="{FF2B5EF4-FFF2-40B4-BE49-F238E27FC236}">
-                <a16:creationId xmlns:a16="http://schemas.microsoft.com/office/drawing/2014/main" id="{E411D2BF-A84C-4E3E-B848-F8B5D1473BAB}"/>
-              </a:ext>
-            </a:extLst>
-          </p:cNvPr>
-          <p:cNvSpPr>
-            <a:spLocks xmlns:a="http://schemas.openxmlformats.org/drawingml/2006/main" noGrp="1"/>
-          </p:cNvSpPr>
-          <p:nvPr/>
-        </p:nvSpPr>
-        <p:spPr>
-          <a:xfrm xmlns:a="http://schemas.openxmlformats.org/drawingml/2006/main">
-            <a:off x="0" y="0"/>
-            <a:ext cx="5810250" cy="12858750"/>
-          </a:xfrm>
-          <a:prstGeom xmlns:a="http://schemas.openxmlformats.org/drawingml/2006/main" prst="rect">
-            <a:avLst/>
-          </a:prstGeom>
-          <a:solidFill xmlns:a="http://schemas.openxmlformats.org/drawingml/2006/main">
-            <a:srgbClr val="080808"/>
-          </a:solidFill>
-          <a:ln xmlns:a="http://schemas.openxmlformats.org/drawingml/2006/main" w="0">
-            <a:noFill/>
-          </a:ln>
-        </p:spPr>
-      </p:sp>
-      <p:sp>
-        <p:nvSpPr>
-          <p:cNvPr id="3" name="">
-            <a:extLst xmlns:a="http://schemas.openxmlformats.org/drawingml/2006/main">
-              <a:ext uri="{FF2B5EF4-FFF2-40B4-BE49-F238E27FC236}">
-                <a16:creationId xmlns:a16="http://schemas.microsoft.com/office/drawing/2014/main" id="{8EBCDAEA-AE1B-4770-B2F7-E26499A4EB34}"/>
-              </a:ext>
-            </a:extLst>
-          </p:cNvPr>
-          <p:cNvSpPr>
-            <a:spLocks xmlns:a="http://schemas.openxmlformats.org/drawingml/2006/main" noGrp="1"/>
-          </p:cNvSpPr>
-          <p:nvPr/>
-        </p:nvSpPr>
-        <p:spPr>
-          <a:xfrm xmlns:a="http://schemas.openxmlformats.org/drawingml/2006/main">
-            <a:off x="5810250" y="0"/>
-            <a:ext cx="1428750" cy="12858750"/>
-          </a:xfrm>
-          <a:prstGeom xmlns:a="http://schemas.openxmlformats.org/drawingml/2006/main" prst="rect">
-            <a:avLst/>
-          </a:prstGeom>
-          <a:gradFill xmlns:a="http://schemas.openxmlformats.org/drawingml/2006/main">
-            <a:gsLst>
-              <a:gs pos="0">
-                <a:srgbClr val="080808"/>
-              </a:gs>
-              <a:gs pos="100000">
-                <a:srgbClr val="080808">
-                  <a:alpha val="0"/>
-                </a:srgbClr>
-              </a:gs>
-            </a:gsLst>
-            <a:lin ang="0"/>
-          </a:gradFill>
-          <a:ln xmlns:a="http://schemas.openxmlformats.org/drawingml/2006/main" w="0">
-            <a:noFill/>
-          </a:ln>
-        </p:spPr>
-      </p:sp>
-      <p:sp>
-        <p:nvSpPr>
-          <p:cNvPr id="4" name="">
-            <a:extLst xmlns:a="http://schemas.openxmlformats.org/drawingml/2006/main">
-              <a:ext uri="{FF2B5EF4-FFF2-40B4-BE49-F238E27FC236}">
-                <a16:creationId xmlns:a16="http://schemas.microsoft.com/office/drawing/2014/main" id="{49B150AF-93A0-4822-9FEE-76961547339F}"/>
-              </a:ext>
-            </a:extLst>
-          </p:cNvPr>
-          <p:cNvSpPr>
-            <a:spLocks xmlns:a="http://schemas.openxmlformats.org/drawingml/2006/main" noGrp="1"/>
-          </p:cNvSpPr>
-          <p:nvPr/>
-        </p:nvSpPr>
-        <p:spPr>
-          <a:xfrm xmlns:a="http://schemas.openxmlformats.org/drawingml/2006/main">
-            <a:off x="762000" y="952500"/>
-            <a:ext cx="3143250" cy="428625"/>
+                <a16:creationId xmlns:a16="http://schemas.microsoft.com/office/drawing/2014/main" id="{138F96AE-F78E-4886-A9FF-0F7B6B7F838D}"/>
+              </a:ext>
+            </a:extLst>
+          </p:cNvPr>
+          <p:cNvSpPr>
+            <a:spLocks xmlns:a="http://schemas.openxmlformats.org/drawingml/2006/main" noGrp="1"/>
+          </p:cNvSpPr>
+          <p:nvPr/>
+        </p:nvSpPr>
+        <p:spPr>
+          <a:xfrm xmlns:a="http://schemas.openxmlformats.org/drawingml/2006/main">
+            <a:off x="762000" y="2095500"/>
+            <a:ext cx="8763000" cy="2857500"/>
           </a:xfrm>
           <a:prstGeom xmlns:a="http://schemas.openxmlformats.org/drawingml/2006/main" prst="rect">
             <a:avLst/>
@@ -8601,71 +8453,10 @@
           <a:p xmlns:a="http://schemas.openxmlformats.org/drawingml/2006/main">
             <a:pPr algn="l">
               <a:lnSpc>
-                <a:spcPct val="100000"/>
-              </a:lnSpc>
-              <a:buNone/>
-              <a:defRPr sz="1875" b="1">
-                <a:solidFill>
-                  <a:srgbClr val="C8FF00"/>
-                </a:solidFill>
-                <a:latin typeface="Menlo"/>
-                <a:ea typeface="Menlo"/>
-                <a:cs typeface="Menlo"/>
-              </a:defRPr>
-            </a:pPr>
-            <a:r>
-              <a:rPr sz="1875" b="1">
-                <a:solidFill>
-                  <a:srgbClr val="C8FF00"/>
-                </a:solidFill>
-                <a:latin typeface="Menlo"/>
-                <a:ea typeface="Menlo"/>
-                <a:cs typeface="Menlo"/>
-              </a:rPr>
-              <a:t>RESUMEN</a:t>
-            </a:r>
-          </a:p>
-        </p:txBody>
-      </p:sp>
-      <p:sp>
-        <p:nvSpPr>
-          <p:cNvPr id="5" name="">
-            <a:extLst xmlns:a="http://schemas.openxmlformats.org/drawingml/2006/main">
-              <a:ext uri="{FF2B5EF4-FFF2-40B4-BE49-F238E27FC236}">
-                <a16:creationId xmlns:a16="http://schemas.microsoft.com/office/drawing/2014/main" id="{E98A38EE-AFBA-4A22-BF8C-017A4372217F}"/>
-              </a:ext>
-            </a:extLst>
-          </p:cNvPr>
-          <p:cNvSpPr>
-            <a:spLocks xmlns:a="http://schemas.openxmlformats.org/drawingml/2006/main" noGrp="1"/>
-          </p:cNvSpPr>
-          <p:nvPr/>
-        </p:nvSpPr>
-        <p:spPr>
-          <a:xfrm xmlns:a="http://schemas.openxmlformats.org/drawingml/2006/main">
-            <a:off x="762000" y="1809750"/>
-            <a:ext cx="5810250" cy="2857500"/>
-          </a:xfrm>
-          <a:prstGeom xmlns:a="http://schemas.openxmlformats.org/drawingml/2006/main" prst="rect">
-            <a:avLst/>
-          </a:prstGeom>
-          <a:noFill xmlns:a="http://schemas.openxmlformats.org/drawingml/2006/main"/>
-          <a:ln xmlns:a="http://schemas.openxmlformats.org/drawingml/2006/main" w="0">
-            <a:noFill/>
-          </a:ln>
-        </p:spPr>
-        <p:txBody>
-          <a:bodyPr xmlns:a="http://schemas.openxmlformats.org/drawingml/2006/main" lIns="0" tIns="0" rIns="0" bIns="0" anchor="t">
-            <a:noAutofit/>
-          </a:bodyPr>
-          <a:lstStyle xmlns:a="http://schemas.openxmlformats.org/drawingml/2006/main"/>
-          <a:p xmlns:a="http://schemas.openxmlformats.org/drawingml/2006/main">
-            <a:pPr algn="l">
-              <a:lnSpc>
                 <a:spcPct val="94000"/>
               </a:lnSpc>
               <a:buNone/>
-              <a:defRPr sz="5175" b="1">
+              <a:defRPr sz="5700" b="1">
                 <a:solidFill>
                   <a:srgbClr val="F7F7F5"/>
                 </a:solidFill>
@@ -8675,7 +8466,7 @@
               </a:defRPr>
             </a:pPr>
             <a:r>
-              <a:rPr sz="5175" b="1">
+              <a:rPr sz="5700" b="1">
                 <a:solidFill>
                   <a:srgbClr val="F7F7F5"/>
                 </a:solidFill>
@@ -8692,7 +8483,7 @@
                 <a:spcPct val="94000"/>
               </a:lnSpc>
               <a:buNone/>
-              <a:defRPr sz="5175" b="1">
+              <a:defRPr sz="5700" b="1">
                 <a:solidFill>
                   <a:srgbClr val="F7F7F5"/>
                 </a:solidFill>
@@ -8702,7 +8493,7 @@
               </a:defRPr>
             </a:pPr>
             <a:r>
-              <a:rPr sz="5175" b="1">
+              <a:rPr sz="5700" b="1">
                 <a:solidFill>
                   <a:srgbClr val="F7F7F5"/>
                 </a:solidFill>
@@ -8710,29 +8501,51 @@
                 <a:ea typeface="Arial Black"/>
                 <a:cs typeface="Arial Black"/>
               </a:rPr>
-              <a:t>Las encierra.</a:t>
-            </a:r>
-          </a:p>
-        </p:txBody>
-      </p:sp>
-      <p:sp>
-        <p:nvSpPr>
-          <p:cNvPr id="6" name="">
-            <a:extLst xmlns:a="http://schemas.openxmlformats.org/drawingml/2006/main">
-              <a:ext uri="{FF2B5EF4-FFF2-40B4-BE49-F238E27FC236}">
-                <a16:creationId xmlns:a16="http://schemas.microsoft.com/office/drawing/2014/main" id="{2A371BAC-B952-48BB-AD1C-66FA8ACC1949}"/>
-              </a:ext>
-            </a:extLst>
-          </p:cNvPr>
-          <p:cNvSpPr>
-            <a:spLocks xmlns:a="http://schemas.openxmlformats.org/drawingml/2006/main" noGrp="1"/>
-          </p:cNvSpPr>
-          <p:nvPr/>
-        </p:nvSpPr>
-        <p:spPr>
-          <a:xfrm xmlns:a="http://schemas.openxmlformats.org/drawingml/2006/main">
-            <a:off x="762000" y="5334000"/>
-            <a:ext cx="5334000" cy="1905000"/>
+              <a:t>Las </a:t>
+            </a:r>
+            <a:r>
+              <a:rPr sz="5700" b="1">
+                <a:solidFill>
+                  <a:srgbClr val="C8FF00"/>
+                </a:solidFill>
+                <a:latin typeface="Arial Black"/>
+                <a:ea typeface="Arial Black"/>
+                <a:cs typeface="Arial Black"/>
+              </a:rPr>
+              <a:t>encierra</a:t>
+            </a:r>
+            <a:r>
+              <a:rPr sz="5700" b="1">
+                <a:solidFill>
+                  <a:srgbClr val="F7F7F5"/>
+                </a:solidFill>
+                <a:latin typeface="Arial Black"/>
+                <a:ea typeface="Arial Black"/>
+                <a:cs typeface="Arial Black"/>
+              </a:rPr>
+              <a:t>.</a:t>
+            </a:r>
+          </a:p>
+        </p:txBody>
+      </p:sp>
+      <p:sp>
+        <p:nvSpPr>
+          <p:cNvPr id="3" name="">
+            <a:extLst xmlns:a="http://schemas.openxmlformats.org/drawingml/2006/main">
+              <a:ext uri="{FF2B5EF4-FFF2-40B4-BE49-F238E27FC236}">
+                <a16:creationId xmlns:a16="http://schemas.microsoft.com/office/drawing/2014/main" id="{81037B6C-0F50-4F0D-8E2C-1597D6E713E8}"/>
+              </a:ext>
+            </a:extLst>
+          </p:cNvPr>
+          <p:cNvSpPr>
+            <a:spLocks xmlns:a="http://schemas.openxmlformats.org/drawingml/2006/main" noGrp="1"/>
+          </p:cNvSpPr>
+          <p:nvPr/>
+        </p:nvSpPr>
+        <p:spPr>
+          <a:xfrm xmlns:a="http://schemas.openxmlformats.org/drawingml/2006/main">
+            <a:off x="762000" y="5810250"/>
+            <a:ext cx="8382000" cy="1428750"/>
           </a:xfrm>
           <a:prstGeom xmlns:a="http://schemas.openxmlformats.org/drawingml/2006/main" prst="rect">
             <a:avLst/>
@@ -8753,7 +8566,7 @@
                 <a:spcPct val="108000"/>
               </a:lnSpc>
               <a:buNone/>
-              <a:defRPr sz="2550" b="0">
+              <a:defRPr sz="2850" b="0">
                 <a:solidFill>
                   <a:srgbClr val="A1A1AA"/>
                 </a:solidFill>
@@ -8763,7 +8576,7 @@
               </a:defRPr>
             </a:pPr>
             <a:r>
-              <a:rPr sz="2550" b="0">
+              <a:rPr sz="2850" b="0">
                 <a:solidFill>
                   <a:srgbClr val="A1A1AA"/>
                 </a:solidFill>
@@ -8778,52 +8591,22 @@
       </p:sp>
       <p:sp>
         <p:nvSpPr>
-          <p:cNvPr id="7" name="">
-            <a:extLst xmlns:a="http://schemas.openxmlformats.org/drawingml/2006/main">
-              <a:ext uri="{FF2B5EF4-FFF2-40B4-BE49-F238E27FC236}">
-                <a16:creationId xmlns:a16="http://schemas.microsoft.com/office/drawing/2014/main" id="{2865A48F-D4C2-490A-8D80-A02F2157D3E3}"/>
-              </a:ext>
-            </a:extLst>
-          </p:cNvPr>
-          <p:cNvSpPr>
-            <a:spLocks xmlns:a="http://schemas.openxmlformats.org/drawingml/2006/main" noGrp="1"/>
-          </p:cNvSpPr>
-          <p:nvPr/>
-        </p:nvSpPr>
-        <p:spPr>
-          <a:xfrm xmlns:a="http://schemas.openxmlformats.org/drawingml/2006/main">
-            <a:off x="762000" y="7905750"/>
-            <a:ext cx="2857500" cy="0"/>
-          </a:xfrm>
-          <a:prstGeom xmlns:a="http://schemas.openxmlformats.org/drawingml/2006/main" prst="line">
-            <a:avLst/>
-          </a:prstGeom>
-          <a:noFill xmlns:a="http://schemas.openxmlformats.org/drawingml/2006/main"/>
-          <a:ln xmlns:a="http://schemas.openxmlformats.org/drawingml/2006/main" w="76200">
-            <a:solidFill>
-              <a:srgbClr val="C8FF00"/>
-            </a:solidFill>
-          </a:ln>
-        </p:spPr>
-      </p:sp>
-      <p:sp>
-        <p:nvSpPr>
-          <p:cNvPr id="8" name="">
-            <a:extLst xmlns:a="http://schemas.openxmlformats.org/drawingml/2006/main">
-              <a:ext uri="{FF2B5EF4-FFF2-40B4-BE49-F238E27FC236}">
-                <a16:creationId xmlns:a16="http://schemas.microsoft.com/office/drawing/2014/main" id="{ED7E3D09-0C2A-433A-B46F-106EE5934E5B}"/>
-              </a:ext>
-            </a:extLst>
-          </p:cNvPr>
-          <p:cNvSpPr>
-            <a:spLocks xmlns:a="http://schemas.openxmlformats.org/drawingml/2006/main" noGrp="1"/>
-          </p:cNvSpPr>
-          <p:nvPr/>
-        </p:nvSpPr>
-        <p:spPr>
-          <a:xfrm xmlns:a="http://schemas.openxmlformats.org/drawingml/2006/main">
-            <a:off x="762000" y="8477250"/>
-            <a:ext cx="4095750" cy="619125"/>
+          <p:cNvPr id="4" name="">
+            <a:extLst xmlns:a="http://schemas.openxmlformats.org/drawingml/2006/main">
+              <a:ext uri="{FF2B5EF4-FFF2-40B4-BE49-F238E27FC236}">
+                <a16:creationId xmlns:a16="http://schemas.microsoft.com/office/drawing/2014/main" id="{736C4B82-86EC-4CF7-B42B-8335AEC0C305}"/>
+              </a:ext>
+            </a:extLst>
+          </p:cNvPr>
+          <p:cNvSpPr>
+            <a:spLocks xmlns:a="http://schemas.openxmlformats.org/drawingml/2006/main" noGrp="1"/>
+          </p:cNvSpPr>
+          <p:nvPr/>
+        </p:nvSpPr>
+        <p:spPr>
+          <a:xfrm xmlns:a="http://schemas.openxmlformats.org/drawingml/2006/main">
+            <a:off x="762000" y="8191500"/>
+            <a:ext cx="6667500" cy="666750"/>
           </a:xfrm>
           <a:prstGeom xmlns:a="http://schemas.openxmlformats.org/drawingml/2006/main" prst="rect">
             <a:avLst/>
@@ -8844,7 +8627,7 @@
                 <a:spcPct val="100000"/>
               </a:lnSpc>
               <a:buNone/>
-              <a:defRPr sz="2925" b="1">
+              <a:defRPr sz="3300" b="1">
                 <a:solidFill>
                   <a:srgbClr val="F7F7F5"/>
                 </a:solidFill>
@@ -8854,7 +8637,7 @@
               </a:defRPr>
             </a:pPr>
             <a:r>
-              <a:rPr sz="2925" b="1">
+              <a:rPr sz="3300" b="1">
                 <a:solidFill>
                   <a:srgbClr val="F7F7F5"/>
                 </a:solidFill>
@@ -8869,22 +8652,22 @@
       </p:sp>
       <p:sp>
         <p:nvSpPr>
-          <p:cNvPr id="9" name="">
-            <a:extLst xmlns:a="http://schemas.openxmlformats.org/drawingml/2006/main">
-              <a:ext uri="{FF2B5EF4-FFF2-40B4-BE49-F238E27FC236}">
-                <a16:creationId xmlns:a16="http://schemas.microsoft.com/office/drawing/2014/main" id="{BCA6E7F6-1C6C-4B97-9C38-6495D5364D61}"/>
-              </a:ext>
-            </a:extLst>
-          </p:cNvPr>
-          <p:cNvSpPr>
-            <a:spLocks xmlns:a="http://schemas.openxmlformats.org/drawingml/2006/main" noGrp="1"/>
-          </p:cNvSpPr>
-          <p:nvPr/>
-        </p:nvSpPr>
-        <p:spPr>
-          <a:xfrm xmlns:a="http://schemas.openxmlformats.org/drawingml/2006/main">
-            <a:off x="762000" y="9382125"/>
-            <a:ext cx="5143500" cy="1428750"/>
+          <p:cNvPr id="5" name="">
+            <a:extLst xmlns:a="http://schemas.openxmlformats.org/drawingml/2006/main">
+              <a:ext uri="{FF2B5EF4-FFF2-40B4-BE49-F238E27FC236}">
+                <a16:creationId xmlns:a16="http://schemas.microsoft.com/office/drawing/2014/main" id="{AFEECE77-673D-4568-ABBA-4E4F579D75BB}"/>
+              </a:ext>
+            </a:extLst>
+          </p:cNvPr>
+          <p:cNvSpPr>
+            <a:spLocks xmlns:a="http://schemas.openxmlformats.org/drawingml/2006/main" noGrp="1"/>
+          </p:cNvSpPr>
+          <p:nvPr/>
+        </p:nvSpPr>
+        <p:spPr>
+          <a:xfrm xmlns:a="http://schemas.openxmlformats.org/drawingml/2006/main">
+            <a:off x="762000" y="9286875"/>
+            <a:ext cx="8096250" cy="1238250"/>
           </a:xfrm>
           <a:prstGeom xmlns:a="http://schemas.openxmlformats.org/drawingml/2006/main" prst="rect">
             <a:avLst/>
@@ -8905,7 +8688,7 @@
                 <a:spcPct val="100000"/>
               </a:lnSpc>
               <a:buNone/>
-              <a:defRPr sz="2325" b="0">
+              <a:defRPr sz="2550" b="0">
                 <a:solidFill>
                   <a:srgbClr val="F7F7F5"/>
                 </a:solidFill>
@@ -8915,7 +8698,7 @@
               </a:defRPr>
             </a:pPr>
             <a:r>
-              <a:rPr sz="2325" b="0">
+              <a:rPr sz="2550" b="0">
                 <a:solidFill>
                   <a:srgbClr val="F7F7F5"/>
                 </a:solidFill>
@@ -8930,22 +8713,22 @@
       </p:sp>
       <p:sp>
         <p:nvSpPr>
-          <p:cNvPr id="10" name="">
-            <a:extLst xmlns:a="http://schemas.openxmlformats.org/drawingml/2006/main">
-              <a:ext uri="{FF2B5EF4-FFF2-40B4-BE49-F238E27FC236}">
-                <a16:creationId xmlns:a16="http://schemas.microsoft.com/office/drawing/2014/main" id="{530D975B-C351-40C3-B11F-BA924A83A342}"/>
-              </a:ext>
-            </a:extLst>
-          </p:cNvPr>
-          <p:cNvSpPr>
-            <a:spLocks xmlns:a="http://schemas.openxmlformats.org/drawingml/2006/main" noGrp="1"/>
-          </p:cNvSpPr>
-          <p:nvPr/>
-        </p:nvSpPr>
-        <p:spPr>
-          <a:xfrm xmlns:a="http://schemas.openxmlformats.org/drawingml/2006/main">
-            <a:off x="762000" y="11334750"/>
-            <a:ext cx="4095750" cy="476250"/>
+          <p:cNvPr id="6" name="">
+            <a:extLst xmlns:a="http://schemas.openxmlformats.org/drawingml/2006/main">
+              <a:ext uri="{FF2B5EF4-FFF2-40B4-BE49-F238E27FC236}">
+                <a16:creationId xmlns:a16="http://schemas.microsoft.com/office/drawing/2014/main" id="{7CFFBE08-AFBE-4B77-AF90-2A86CCA01DA7}"/>
+              </a:ext>
+            </a:extLst>
+          </p:cNvPr>
+          <p:cNvSpPr>
+            <a:spLocks xmlns:a="http://schemas.openxmlformats.org/drawingml/2006/main" noGrp="1"/>
+          </p:cNvSpPr>
+          <p:nvPr/>
+        </p:nvSpPr>
+        <p:spPr>
+          <a:xfrm xmlns:a="http://schemas.openxmlformats.org/drawingml/2006/main">
+            <a:off x="762000" y="11191875"/>
+            <a:ext cx="6667500" cy="476250"/>
           </a:xfrm>
           <a:prstGeom xmlns:a="http://schemas.openxmlformats.org/drawingml/2006/main" prst="rect">
             <a:avLst/>
@@ -8966,7 +8749,7 @@
                 <a:spcPct val="100000"/>
               </a:lnSpc>
               <a:buNone/>
-              <a:defRPr sz="2025" b="1">
+              <a:defRPr sz="2250" b="1">
                 <a:solidFill>
                   <a:srgbClr val="C8FF00"/>
                 </a:solidFill>
@@ -8976,7 +8759,7 @@
               </a:defRPr>
             </a:pPr>
             <a:r>
-              <a:rPr sz="2025" b="1">
+              <a:rPr sz="2250" b="1">
                 <a:solidFill>
                   <a:srgbClr val="C8FF00"/>
                 </a:solidFill>
@@ -8991,10 +8774,10 @@
       </p:sp>
       <p:sp>
         <p:nvSpPr>
-          <p:cNvPr id="11" name="">
-            <a:extLst xmlns:a="http://schemas.openxmlformats.org/drawingml/2006/main">
-              <a:ext uri="{FF2B5EF4-FFF2-40B4-BE49-F238E27FC236}">
-                <a16:creationId xmlns:a16="http://schemas.microsoft.com/office/drawing/2014/main" id="{A9C205F1-B615-4954-8D77-A7CE8F80F6D1}"/>
+          <p:cNvPr id="7" name="">
+            <a:extLst xmlns:a="http://schemas.openxmlformats.org/drawingml/2006/main">
+              <a:ext uri="{FF2B5EF4-FFF2-40B4-BE49-F238E27FC236}">
+                <a16:creationId xmlns:a16="http://schemas.microsoft.com/office/drawing/2014/main" id="{5DCEE1C4-B225-4556-81E1-7E91D041C1AA}"/>
               </a:ext>
             </a:extLst>
           </p:cNvPr>
@@ -9053,7 +8836,7 @@
     </p:spTree>
     <p:extLst>
       <p:ext uri="{BB962C8B-B14F-4D97-AF65-F5344CB8AC3E}">
-        <p14:creationId xmlns:p14="http://schemas.microsoft.com/office/powerpoint/2010/main" val="1951608987"/>
+        <p14:creationId xmlns:p14="http://schemas.microsoft.com/office/powerpoint/2010/main" val="1153785495"/>
       </p:ext>
     </p:extLst>
   </p:cSld>

</xml_diff>